<commit_message>
Review: Update presentation to bright clean theme, remove viva slide, add concurrency representations
</commit_message>
<xml_diff>
--- a/presentation.pptx
+++ b/presentation.pptx
@@ -3110,11 +3110,11 @@
             <a:avLst/>
           </a:prstGeom>
           <a:solidFill>
-            <a:srgbClr val="0B0F19"/>
+            <a:srgbClr val="F8FAFC"/>
           </a:solidFill>
           <a:ln>
             <a:solidFill>
-              <a:srgbClr val="0B0F19"/>
+              <a:srgbClr val="F8FAFC"/>
             </a:solidFill>
           </a:ln>
         </p:spPr>
@@ -3148,18 +3148,18 @@
         </p:nvSpPr>
         <p:spPr>
           <a:xfrm>
-            <a:off x="4114800" y="822960"/>
-            <a:ext cx="3959352" cy="411480"/>
+            <a:off x="3931920" y="731520"/>
+            <a:ext cx="4297680" cy="411480"/>
           </a:xfrm>
           <a:prstGeom prst="roundRect">
             <a:avLst/>
           </a:prstGeom>
           <a:solidFill>
-            <a:srgbClr val="0F233C"/>
+            <a:srgbClr val="E0F2FE"/>
           </a:solidFill>
           <a:ln>
             <a:solidFill>
-              <a:srgbClr val="38BDF8"/>
+              <a:srgbClr val="0284C7"/>
             </a:solidFill>
           </a:ln>
         </p:spPr>
@@ -3184,7 +3184,7 @@
             <a:pPr algn="ctr">
               <a:defRPr sz="1100" b="1">
                 <a:solidFill>
-                  <a:srgbClr val="38BDF8"/>
+                  <a:srgbClr val="0284C7"/>
                 </a:solidFill>
               </a:defRPr>
             </a:pPr>
@@ -3202,7 +3202,7 @@
         </p:nvSpPr>
         <p:spPr>
           <a:xfrm>
-            <a:off x="914400" y="1371600"/>
+            <a:off x="914400" y="1280160"/>
             <a:ext cx="10360152" cy="1645920"/>
           </a:xfrm>
           <a:prstGeom prst="rect">
@@ -3219,7 +3219,7 @@
             <a:pPr algn="ctr">
               <a:defRPr sz="4000" b="1">
                 <a:solidFill>
-                  <a:srgbClr val="38BDF8"/>
+                  <a:srgbClr val="0F172A"/>
                 </a:solidFill>
               </a:defRPr>
             </a:pPr>
@@ -3230,11 +3230,11 @@
           <a:p>
             <a:pPr algn="ctr">
               <a:spcBef>
-                <a:spcPts val="1000"/>
+                <a:spcPts val="800"/>
               </a:spcBef>
-              <a:defRPr sz="1700">
-                <a:solidFill>
-                  <a:srgbClr val="94A3B8"/>
+              <a:defRPr sz="1600">
+                <a:solidFill>
+                  <a:srgbClr val="475569"/>
                 </a:solidFill>
               </a:defRPr>
             </a:pPr>
@@ -3243,7 +3243,7 @@
             </a:r>
             <a:br/>
             <a:r>
-              <a:t>Using Linux Namespaces and Unified Cgroups v2</a:t>
+              <a:t>Utilizing Linux Namespaces, Unified Cgroups v2, and VFS Sandboxing</a:t>
             </a:r>
           </a:p>
         </p:txBody>
@@ -3256,18 +3256,18 @@
         </p:nvSpPr>
         <p:spPr>
           <a:xfrm>
-            <a:off x="2011680" y="3383280"/>
-            <a:ext cx="3840480" cy="1920240"/>
+            <a:off x="2011680" y="3291840"/>
+            <a:ext cx="3840480" cy="2103120"/>
           </a:xfrm>
           <a:prstGeom prst="roundRect">
             <a:avLst/>
           </a:prstGeom>
           <a:solidFill>
-            <a:srgbClr val="151D30"/>
+            <a:srgbClr val="FFFFFF"/>
           </a:solidFill>
           <a:ln w="25400">
             <a:solidFill>
-              <a:srgbClr val="38BDF8"/>
+              <a:srgbClr val="0284C7"/>
             </a:solidFill>
           </a:ln>
         </p:spPr>
@@ -3292,7 +3292,7 @@
             <a:pPr algn="ctr">
               <a:defRPr sz="1000" b="1">
                 <a:solidFill>
-                  <a:srgbClr val="818CF8"/>
+                  <a:srgbClr val="0284C7"/>
                 </a:solidFill>
               </a:defRPr>
             </a:pPr>
@@ -3302,9 +3302,9 @@
           </a:p>
           <a:p>
             <a:pPr>
-              <a:defRPr sz="1900" b="1">
-                <a:solidFill>
-                  <a:srgbClr val="F1F5F9"/>
+              <a:defRPr sz="2000" b="1">
+                <a:solidFill>
+                  <a:srgbClr val="0F172A"/>
                 </a:solidFill>
               </a:defRPr>
             </a:pPr>
@@ -3317,18 +3317,22 @@
               <a:spcBef>
                 <a:spcPts val="400"/>
               </a:spcBef>
-              <a:defRPr sz="1200">
-                <a:solidFill>
-                  <a:srgbClr val="38BDF8"/>
-                </a:solidFill>
-              </a:defRPr>
-            </a:pPr>
-            <a:r>
-              <a:t>Reg No: 24BCE2538</a:t>
+              <a:defRPr sz="1100">
+                <a:solidFill>
+                  <a:srgbClr val="475569"/>
+                </a:solidFill>
+              </a:defRPr>
+            </a:pPr>
+            <a:r>
+              <a:t>Register No: 24BCE2538</a:t>
             </a:r>
             <a:br/>
             <a:r>
               <a:t>B.Tech Computer Science &amp; Engineering</a:t>
+            </a:r>
+            <a:br/>
+            <a:r>
+              <a:t>Core Developer (Namespaces &amp; Cgroups)</a:t>
             </a:r>
           </a:p>
         </p:txBody>
@@ -3341,18 +3345,18 @@
         </p:nvSpPr>
         <p:spPr>
           <a:xfrm>
-            <a:off x="6309360" y="3383280"/>
-            <a:ext cx="3840480" cy="1920240"/>
+            <a:off x="6309360" y="3291840"/>
+            <a:ext cx="3840480" cy="2103120"/>
           </a:xfrm>
           <a:prstGeom prst="roundRect">
             <a:avLst/>
           </a:prstGeom>
           <a:solidFill>
-            <a:srgbClr val="151D30"/>
+            <a:srgbClr val="FFFFFF"/>
           </a:solidFill>
           <a:ln w="25400">
             <a:solidFill>
-              <a:srgbClr val="818CF8"/>
+              <a:srgbClr val="4F46E5"/>
             </a:solidFill>
           </a:ln>
         </p:spPr>
@@ -3377,7 +3381,7 @@
             <a:pPr algn="ctr">
               <a:defRPr sz="1000" b="1">
                 <a:solidFill>
-                  <a:srgbClr val="818CF8"/>
+                  <a:srgbClr val="4F46E5"/>
                 </a:solidFill>
               </a:defRPr>
             </a:pPr>
@@ -3387,9 +3391,9 @@
           </a:p>
           <a:p>
             <a:pPr>
-              <a:defRPr sz="1900" b="1">
-                <a:solidFill>
-                  <a:srgbClr val="F1F5F9"/>
+              <a:defRPr sz="2000" b="1">
+                <a:solidFill>
+                  <a:srgbClr val="0F172A"/>
                 </a:solidFill>
               </a:defRPr>
             </a:pPr>
@@ -3402,18 +3406,22 @@
               <a:spcBef>
                 <a:spcPts val="400"/>
               </a:spcBef>
-              <a:defRPr sz="1200">
-                <a:solidFill>
-                  <a:srgbClr val="818CF8"/>
-                </a:solidFill>
-              </a:defRPr>
-            </a:pPr>
-            <a:r>
-              <a:t>Reg No: 24BCE2805</a:t>
+              <a:defRPr sz="1100">
+                <a:solidFill>
+                  <a:srgbClr val="475569"/>
+                </a:solidFill>
+              </a:defRPr>
+            </a:pPr>
+            <a:r>
+              <a:t>Register No: 24BCE2805</a:t>
             </a:r>
             <a:br/>
             <a:r>
               <a:t>B.Tech Computer Science &amp; Engineering</a:t>
+            </a:r>
+            <a:br/>
+            <a:r>
+              <a:t>Core Developer (Concurrency &amp; Testing)</a:t>
             </a:r>
           </a:p>
         </p:txBody>
@@ -3427,7 +3435,7 @@
         <p:spPr>
           <a:xfrm>
             <a:off x="914400" y="5760720"/>
-            <a:ext cx="10360152" cy="548640"/>
+            <a:ext cx="10360152" cy="457200"/>
           </a:xfrm>
           <a:prstGeom prst="rect">
             <a:avLst/>
@@ -3441,14 +3449,14 @@
           <a:lstStyle/>
           <a:p>
             <a:pPr algn="ctr">
-              <a:defRPr sz="1300">
-                <a:solidFill>
-                  <a:srgbClr val="38BDF8"/>
-                </a:solidFill>
-              </a:defRPr>
-            </a:pPr>
-            <a:r>
-              <a:t>Repository: https://github.com/THARAKESHA/mini-container</a:t>
+              <a:defRPr sz="1200" b="1">
+                <a:solidFill>
+                  <a:srgbClr val="0284C7"/>
+                </a:solidFill>
+              </a:defRPr>
+            </a:pPr>
+            <a:r>
+              <a:t>GitHub Repository: https://github.com/THARAKESHA/mini-container</a:t>
             </a:r>
           </a:p>
         </p:txBody>
@@ -3486,11 +3494,11 @@
             <a:avLst/>
           </a:prstGeom>
           <a:solidFill>
-            <a:srgbClr val="0B0F19"/>
+            <a:srgbClr val="F8FAFC"/>
           </a:solidFill>
           <a:ln>
             <a:solidFill>
-              <a:srgbClr val="0B0F19"/>
+              <a:srgbClr val="F8FAFC"/>
             </a:solidFill>
           </a:ln>
         </p:spPr>
@@ -3525,7 +3533,7 @@
         <p:spPr>
           <a:xfrm>
             <a:off x="731520" y="365760"/>
-            <a:ext cx="10515600" cy="365760"/>
+            <a:ext cx="10698480" cy="320040"/>
           </a:xfrm>
           <a:prstGeom prst="rect">
             <a:avLst/>
@@ -3541,12 +3549,12 @@
             <a:pPr>
               <a:defRPr sz="1100" b="1">
                 <a:solidFill>
-                  <a:srgbClr val="818CF8"/>
-                </a:solidFill>
-              </a:defRPr>
-            </a:pPr>
-            <a:r>
-              <a:t>CONCEPT &amp; OBJECTIVES</a:t>
+                  <a:srgbClr val="0284C7"/>
+                </a:solidFill>
+              </a:defRPr>
+            </a:pPr>
+            <a:r>
+              <a:t>PROBLEM STATEMENT &amp; CONCEPTS</a:t>
             </a:r>
           </a:p>
         </p:txBody>
@@ -3559,8 +3567,8 @@
         </p:nvSpPr>
         <p:spPr>
           <a:xfrm>
-            <a:off x="731520" y="640080"/>
-            <a:ext cx="10515600" cy="640080"/>
+            <a:off x="731520" y="621792"/>
+            <a:ext cx="10698480" cy="640080"/>
           </a:xfrm>
           <a:prstGeom prst="rect">
             <a:avLst/>
@@ -3576,12 +3584,12 @@
             <a:pPr>
               <a:defRPr sz="2400" b="1">
                 <a:solidFill>
-                  <a:srgbClr val="F1F5F9"/>
-                </a:solidFill>
-              </a:defRPr>
-            </a:pPr>
-            <a:r>
-              <a:t>Motivation: Containers vs. Virtual Machines</a:t>
+                  <a:srgbClr val="0F172A"/>
+                </a:solidFill>
+              </a:defRPr>
+            </a:pPr>
+            <a:r>
+              <a:t>Motivation: OS Virtualization vs. Hardware Emulation</a:t>
             </a:r>
           </a:p>
         </p:txBody>
@@ -3594,18 +3602,18 @@
         </p:nvSpPr>
         <p:spPr>
           <a:xfrm>
-            <a:off x="731520" y="1325880"/>
-            <a:ext cx="10698480" cy="18288"/>
+            <a:off x="731520" y="1298448"/>
+            <a:ext cx="10698480" cy="27432"/>
           </a:xfrm>
           <a:prstGeom prst="rect">
             <a:avLst/>
           </a:prstGeom>
           <a:solidFill>
-            <a:srgbClr val="243354"/>
+            <a:srgbClr val="0284C7"/>
           </a:solidFill>
           <a:ln>
             <a:solidFill>
-              <a:srgbClr val="243354"/>
+              <a:srgbClr val="0284C7"/>
             </a:solidFill>
           </a:ln>
         </p:spPr>
@@ -3639,18 +3647,18 @@
         </p:nvSpPr>
         <p:spPr>
           <a:xfrm>
-            <a:off x="731520" y="1645920"/>
-            <a:ext cx="5120640" cy="4480560"/>
+            <a:off x="731520" y="1600200"/>
+            <a:ext cx="5120640" cy="3657600"/>
           </a:xfrm>
           <a:prstGeom prst="roundRect">
             <a:avLst/>
           </a:prstGeom>
           <a:solidFill>
-            <a:srgbClr val="151D30"/>
+            <a:srgbClr val="FFFFFF"/>
           </a:solidFill>
           <a:ln w="19050">
             <a:solidFill>
-              <a:srgbClr val="243354"/>
+              <a:srgbClr val="CBD5E1"/>
             </a:solidFill>
           </a:ln>
         </p:spPr>
@@ -3678,137 +3686,24 @@
       </p:sp>
       <p:sp>
         <p:nvSpPr>
-          <p:cNvPr id="7" name="TextBox 6"/>
-          <p:cNvSpPr txBox="1"/>
-          <p:nvPr/>
-        </p:nvSpPr>
-        <p:spPr>
-          <a:xfrm>
-            <a:off x="914400" y="1828800"/>
-            <a:ext cx="4754880" cy="4114800"/>
-          </a:xfrm>
-          <a:prstGeom prst="rect">
-            <a:avLst/>
-          </a:prstGeom>
-          <a:noFill/>
-        </p:spPr>
-        <p:txBody>
-          <a:bodyPr wrap="square">
-            <a:spAutoFit/>
-          </a:bodyPr>
-          <a:lstStyle/>
-          <a:p>
-            <a:pPr>
-              <a:spcAft>
-                <a:spcPts val="1000"/>
-              </a:spcAft>
-              <a:defRPr sz="1600" b="1">
-                <a:solidFill>
-                  <a:srgbClr val="F59E0B"/>
-                </a:solidFill>
-              </a:defRPr>
-            </a:pPr>
-            <a:r>
-              <a:t>Traditional Virtual Machines (VMs)</a:t>
-            </a:r>
-          </a:p>
-          <a:p>
-            <a:pPr>
-              <a:spcAft>
-                <a:spcPts val="800"/>
-              </a:spcAft>
-              <a:defRPr sz="1300">
-                <a:solidFill>
-                  <a:srgbClr val="F1F5F9"/>
-                </a:solidFill>
-              </a:defRPr>
-            </a:pPr>
-            <a:r>
-              <a:t>•  Virtualize the hardware layer using a hypervisor (Type-1/Type-2).</a:t>
-            </a:r>
-          </a:p>
-          <a:p>
-            <a:pPr>
-              <a:spcAft>
-                <a:spcPts val="800"/>
-              </a:spcAft>
-              <a:defRPr sz="1300">
-                <a:solidFill>
-                  <a:srgbClr val="F1F5F9"/>
-                </a:solidFill>
-              </a:defRPr>
-            </a:pPr>
-            <a:r>
-              <a:t>•  Requires a separate, complete guest OS kernel per virtual machine.</a:t>
-            </a:r>
-          </a:p>
-          <a:p>
-            <a:pPr>
-              <a:spcAft>
-                <a:spcPts val="800"/>
-              </a:spcAft>
-              <a:defRPr sz="1300">
-                <a:solidFill>
-                  <a:srgbClr val="F1F5F9"/>
-                </a:solidFill>
-              </a:defRPr>
-            </a:pPr>
-            <a:r>
-              <a:t>•  High memory footprint (Gigabytes) and slow multi-second boot latency.</a:t>
-            </a:r>
-          </a:p>
-          <a:p>
-            <a:pPr>
-              <a:spcAft>
-                <a:spcPts val="800"/>
-              </a:spcAft>
-              <a:defRPr sz="1300">
-                <a:solidFill>
-                  <a:srgbClr val="F1F5F9"/>
-                </a:solidFill>
-              </a:defRPr>
-            </a:pPr>
-            <a:r>
-              <a:t>•  Incurs hardware emulation translation penalties and CPU overhead.</a:t>
-            </a:r>
-          </a:p>
-          <a:p>
-            <a:pPr>
-              <a:spcAft>
-                <a:spcPts val="800"/>
-              </a:spcAft>
-              <a:defRPr sz="1300">
-                <a:solidFill>
-                  <a:srgbClr val="F1F5F9"/>
-                </a:solidFill>
-              </a:defRPr>
-            </a:pPr>
-            <a:r>
-              <a:t>•  Resource limits are rigid and coarse-grained.</a:t>
-            </a:r>
-          </a:p>
-        </p:txBody>
-      </p:sp>
-      <p:sp>
-        <p:nvSpPr>
-          <p:cNvPr id="8" name="Rounded Rectangle 7"/>
+          <p:cNvPr id="7" name="Rounded Rectangle 6"/>
           <p:cNvSpPr/>
           <p:nvPr/>
         </p:nvSpPr>
         <p:spPr>
           <a:xfrm>
-            <a:off x="6217920" y="1645920"/>
-            <a:ext cx="5120640" cy="4480560"/>
+            <a:off x="749808" y="1618488"/>
+            <a:ext cx="5084064" cy="91440"/>
           </a:xfrm>
           <a:prstGeom prst="roundRect">
             <a:avLst/>
           </a:prstGeom>
           <a:solidFill>
-            <a:srgbClr val="151D30"/>
+            <a:srgbClr val="D97706"/>
           </a:solidFill>
-          <a:ln w="19050">
+          <a:ln>
             <a:solidFill>
-              <a:srgbClr val="243354"/>
+              <a:srgbClr val="D97706"/>
             </a:solidFill>
           </a:ln>
         </p:spPr>
@@ -3836,14 +3731,14 @@
       </p:sp>
       <p:sp>
         <p:nvSpPr>
-          <p:cNvPr id="9" name="TextBox 8"/>
+          <p:cNvPr id="8" name="TextBox 7"/>
           <p:cNvSpPr txBox="1"/>
           <p:nvPr/>
         </p:nvSpPr>
         <p:spPr>
           <a:xfrm>
-            <a:off x="6400800" y="1828800"/>
-            <a:ext cx="4754880" cy="4114800"/>
+            <a:off x="960120" y="1801368"/>
+            <a:ext cx="4663440" cy="3337560"/>
           </a:xfrm>
           <a:prstGeom prst="rect">
             <a:avLst/>
@@ -3858,26 +3753,229 @@
           <a:p>
             <a:pPr>
               <a:spcAft>
-                <a:spcPts val="1000"/>
+                <a:spcPts val="800"/>
               </a:spcAft>
-              <a:defRPr sz="1600" b="1">
-                <a:solidFill>
-                  <a:srgbClr val="34D399"/>
-                </a:solidFill>
-              </a:defRPr>
-            </a:pPr>
-            <a:r>
-              <a:t>OS-Level Containers (mini-container)</a:t>
-            </a:r>
-          </a:p>
+              <a:defRPr sz="1500" b="1">
+                <a:solidFill>
+                  <a:srgbClr val="D97706"/>
+                </a:solidFill>
+              </a:defRPr>
+            </a:pPr>
+            <a:r>
+              <a:t>Traditional Virtual Machines (Hypervisors)</a:t>
+            </a:r>
+          </a:p>
+          <a:p>
+            <a:pPr>
+              <a:spcAft>
+                <a:spcPts val="600"/>
+              </a:spcAft>
+              <a:defRPr sz="1200">
+                <a:solidFill>
+                  <a:srgbClr val="0F172A"/>
+                </a:solidFill>
+              </a:defRPr>
+            </a:pPr>
+            <a:r>
+              <a:t>•  Virtualizes the physical hardware layer via a hypervisor (Type-1/2).</a:t>
+            </a:r>
+          </a:p>
+          <a:p>
+            <a:pPr>
+              <a:spcAft>
+                <a:spcPts val="600"/>
+              </a:spcAft>
+              <a:defRPr sz="1200">
+                <a:solidFill>
+                  <a:srgbClr val="0F172A"/>
+                </a:solidFill>
+              </a:defRPr>
+            </a:pPr>
+            <a:r>
+              <a:t>•  Requires a dedicated, redundant guest OS kernel per instance.</a:t>
+            </a:r>
+          </a:p>
+          <a:p>
+            <a:pPr>
+              <a:spcAft>
+                <a:spcPts val="600"/>
+              </a:spcAft>
+              <a:defRPr sz="1200">
+                <a:solidFill>
+                  <a:srgbClr val="0F172A"/>
+                </a:solidFill>
+              </a:defRPr>
+            </a:pPr>
+            <a:r>
+              <a:t>•  High memory footprint (1 - 4 GB) and slow boot latency (30 - 60s).</a:t>
+            </a:r>
+          </a:p>
+          <a:p>
+            <a:pPr>
+              <a:spcAft>
+                <a:spcPts val="600"/>
+              </a:spcAft>
+              <a:defRPr sz="1200">
+                <a:solidFill>
+                  <a:srgbClr val="0F172A"/>
+                </a:solidFill>
+              </a:defRPr>
+            </a:pPr>
+            <a:r>
+              <a:t>•  Incurs hardware emulation translation penalties and CPU traps.</a:t>
+            </a:r>
+          </a:p>
+          <a:p>
+            <a:pPr>
+              <a:spcAft>
+                <a:spcPts val="600"/>
+              </a:spcAft>
+              <a:defRPr sz="1200">
+                <a:solidFill>
+                  <a:srgbClr val="0F172A"/>
+                </a:solidFill>
+              </a:defRPr>
+            </a:pPr>
+            <a:r>
+              <a:t>•  Rigid, coarse-grained hardware resource partitioning.</a:t>
+            </a:r>
+          </a:p>
+        </p:txBody>
+      </p:sp>
+      <p:sp>
+        <p:nvSpPr>
+          <p:cNvPr id="9" name="Rounded Rectangle 8"/>
+          <p:cNvSpPr/>
+          <p:nvPr/>
+        </p:nvSpPr>
+        <p:spPr>
+          <a:xfrm>
+            <a:off x="6217920" y="1600200"/>
+            <a:ext cx="5120640" cy="3657600"/>
+          </a:xfrm>
+          <a:prstGeom prst="roundRect">
+            <a:avLst/>
+          </a:prstGeom>
+          <a:solidFill>
+            <a:srgbClr val="FFFFFF"/>
+          </a:solidFill>
+          <a:ln w="19050">
+            <a:solidFill>
+              <a:srgbClr val="CBD5E1"/>
+            </a:solidFill>
+          </a:ln>
+        </p:spPr>
+        <p:style>
+          <a:lnRef idx="1">
+            <a:schemeClr val="accent1"/>
+          </a:lnRef>
+          <a:fillRef idx="3">
+            <a:schemeClr val="accent1"/>
+          </a:fillRef>
+          <a:effectRef idx="2">
+            <a:schemeClr val="accent1"/>
+          </a:effectRef>
+          <a:fontRef idx="minor">
+            <a:schemeClr val="lt1"/>
+          </a:fontRef>
+        </p:style>
+        <p:txBody>
+          <a:bodyPr rtlCol="0" anchor="ctr"/>
+          <a:lstStyle/>
+          <a:p>
+            <a:pPr algn="ctr"/>
+          </a:p>
+        </p:txBody>
+      </p:sp>
+      <p:sp>
+        <p:nvSpPr>
+          <p:cNvPr id="10" name="Rounded Rectangle 9"/>
+          <p:cNvSpPr/>
+          <p:nvPr/>
+        </p:nvSpPr>
+        <p:spPr>
+          <a:xfrm>
+            <a:off x="6236208" y="1618488"/>
+            <a:ext cx="5084064" cy="91440"/>
+          </a:xfrm>
+          <a:prstGeom prst="roundRect">
+            <a:avLst/>
+          </a:prstGeom>
+          <a:solidFill>
+            <a:srgbClr val="10B981"/>
+          </a:solidFill>
+          <a:ln>
+            <a:solidFill>
+              <a:srgbClr val="10B981"/>
+            </a:solidFill>
+          </a:ln>
+        </p:spPr>
+        <p:style>
+          <a:lnRef idx="1">
+            <a:schemeClr val="accent1"/>
+          </a:lnRef>
+          <a:fillRef idx="3">
+            <a:schemeClr val="accent1"/>
+          </a:fillRef>
+          <a:effectRef idx="2">
+            <a:schemeClr val="accent1"/>
+          </a:effectRef>
+          <a:fontRef idx="minor">
+            <a:schemeClr val="lt1"/>
+          </a:fontRef>
+        </p:style>
+        <p:txBody>
+          <a:bodyPr rtlCol="0" anchor="ctr"/>
+          <a:lstStyle/>
+          <a:p>
+            <a:pPr algn="ctr"/>
+          </a:p>
+        </p:txBody>
+      </p:sp>
+      <p:sp>
+        <p:nvSpPr>
+          <p:cNvPr id="11" name="TextBox 10"/>
+          <p:cNvSpPr txBox="1"/>
+          <p:nvPr/>
+        </p:nvSpPr>
+        <p:spPr>
+          <a:xfrm>
+            <a:off x="6446520" y="1801368"/>
+            <a:ext cx="4663440" cy="3337560"/>
+          </a:xfrm>
+          <a:prstGeom prst="rect">
+            <a:avLst/>
+          </a:prstGeom>
+          <a:noFill/>
+        </p:spPr>
+        <p:txBody>
+          <a:bodyPr wrap="square">
+            <a:spAutoFit/>
+          </a:bodyPr>
+          <a:lstStyle/>
           <a:p>
             <a:pPr>
               <a:spcAft>
                 <a:spcPts val="800"/>
               </a:spcAft>
-              <a:defRPr sz="1300">
-                <a:solidFill>
-                  <a:srgbClr val="F1F5F9"/>
+              <a:defRPr sz="1500" b="1">
+                <a:solidFill>
+                  <a:srgbClr val="10B981"/>
+                </a:solidFill>
+              </a:defRPr>
+            </a:pPr>
+            <a:r>
+              <a:t>OS-Level Containers (mini-container in C)</a:t>
+            </a:r>
+          </a:p>
+          <a:p>
+            <a:pPr>
+              <a:spcAft>
+                <a:spcPts val="600"/>
+              </a:spcAft>
+              <a:defRPr sz="1200">
+                <a:solidFill>
+                  <a:srgbClr val="0F172A"/>
                 </a:solidFill>
               </a:defRPr>
             </a:pPr>
@@ -3888,61 +3986,127 @@
           <a:p>
             <a:pPr>
               <a:spcAft>
-                <a:spcPts val="800"/>
+                <a:spcPts val="600"/>
               </a:spcAft>
-              <a:defRPr sz="1300">
-                <a:solidFill>
-                  <a:srgbClr val="F1F5F9"/>
-                </a:solidFill>
-              </a:defRPr>
-            </a:pPr>
-            <a:r>
-              <a:t>•  Containers are regular OS processes wrapped in kernel-enforced boundaries.</a:t>
+              <a:defRPr sz="1200">
+                <a:solidFill>
+                  <a:srgbClr val="0F172A"/>
+                </a:solidFill>
+              </a:defRPr>
+            </a:pPr>
+            <a:r>
+              <a:t>•  Containers are regular OS processes wrapped in kernel-enforced limits.</a:t>
             </a:r>
           </a:p>
           <a:p>
             <a:pPr>
               <a:spcAft>
-                <a:spcPts val="800"/>
+                <a:spcPts val="600"/>
               </a:spcAft>
-              <a:defRPr sz="1300">
-                <a:solidFill>
-                  <a:srgbClr val="F1F5F9"/>
-                </a:solidFill>
-              </a:defRPr>
-            </a:pPr>
-            <a:r>
-              <a:t>•  Sub-second boot times (10-20ms) and minimal RAM overhead (Megabytes).</a:t>
+              <a:defRPr sz="1200">
+                <a:solidFill>
+                  <a:srgbClr val="0F172A"/>
+                </a:solidFill>
+              </a:defRPr>
+            </a:pPr>
+            <a:r>
+              <a:t>•  Sub-second boot times (10-20ms) and minimal RAM overhead (~5MB).</a:t>
             </a:r>
           </a:p>
           <a:p>
             <a:pPr>
               <a:spcAft>
-                <a:spcPts val="800"/>
+                <a:spcPts val="600"/>
               </a:spcAft>
-              <a:defRPr sz="1300">
-                <a:solidFill>
-                  <a:srgbClr val="F1F5F9"/>
-                </a:solidFill>
-              </a:defRPr>
-            </a:pPr>
-            <a:r>
-              <a:t>•  Near-native bare-metal execution performance.</a:t>
+              <a:defRPr sz="1200">
+                <a:solidFill>
+                  <a:srgbClr val="0F172A"/>
+                </a:solidFill>
+              </a:defRPr>
+            </a:pPr>
+            <a:r>
+              <a:t>•  Near-native bare-metal execution performance with hardware quotas.</a:t>
             </a:r>
           </a:p>
           <a:p>
             <a:pPr>
               <a:spcAft>
-                <a:spcPts val="800"/>
+                <a:spcPts val="600"/>
               </a:spcAft>
-              <a:defRPr sz="1300">
-                <a:solidFill>
-                  <a:srgbClr val="F1F5F9"/>
-                </a:solidFill>
-              </a:defRPr>
-            </a:pPr>
-            <a:r>
-              <a:t>•  Cgroups v2 enforces dynamic CPU quotas, memory ceilings, and task limits.</a:t>
+              <a:defRPr sz="1200">
+                <a:solidFill>
+                  <a:srgbClr val="0F172A"/>
+                </a:solidFill>
+              </a:defRPr>
+            </a:pPr>
+            <a:r>
+              <a:t>•  Fine-grained dynamic control via modern Linux Cgroups v2.</a:t>
+            </a:r>
+          </a:p>
+        </p:txBody>
+      </p:sp>
+      <p:sp>
+        <p:nvSpPr>
+          <p:cNvPr id="12" name="Rounded Rectangle 11"/>
+          <p:cNvSpPr/>
+          <p:nvPr/>
+        </p:nvSpPr>
+        <p:spPr>
+          <a:xfrm>
+            <a:off x="731520" y="5440680"/>
+            <a:ext cx="10607040" cy="868680"/>
+          </a:xfrm>
+          <a:prstGeom prst="roundRect">
+            <a:avLst/>
+          </a:prstGeom>
+          <a:solidFill>
+            <a:srgbClr val="FFFFFF"/>
+          </a:solidFill>
+          <a:ln>
+            <a:solidFill>
+              <a:srgbClr val="CBD5E1"/>
+            </a:solidFill>
+          </a:ln>
+        </p:spPr>
+        <p:style>
+          <a:lnRef idx="1">
+            <a:schemeClr val="accent1"/>
+          </a:lnRef>
+          <a:fillRef idx="3">
+            <a:schemeClr val="accent1"/>
+          </a:fillRef>
+          <a:effectRef idx="2">
+            <a:schemeClr val="accent1"/>
+          </a:effectRef>
+          <a:fontRef idx="minor">
+            <a:schemeClr val="lt1"/>
+          </a:fontRef>
+        </p:style>
+        <p:txBody>
+          <a:bodyPr rtlCol="0" anchor="ctr" wrap="square"/>
+          <a:lstStyle/>
+          <a:p>
+            <a:pPr algn="ctr">
+              <a:defRPr sz="1000" b="1">
+                <a:solidFill>
+                  <a:srgbClr val="0284C7"/>
+                </a:solidFill>
+              </a:defRPr>
+            </a:pPr>
+            <a:r>
+              <a:t>EFFICIENCY COMPARISON REPRESENTATION</a:t>
+            </a:r>
+          </a:p>
+          <a:p>
+            <a:pPr>
+              <a:defRPr sz="1100">
+                <a:solidFill>
+                  <a:srgbClr val="0F172A"/>
+                </a:solidFill>
+              </a:defRPr>
+            </a:pPr>
+            <a:r>
+              <a:t>Boot Latency: VM (45,000 ms) vs. Container (15 ms)  |  RAM Overhead: VM (~1500 MB) vs. Container (&lt; 5 MB)  |  CPU Overhead: ~0.1%</a:t>
             </a:r>
           </a:p>
         </p:txBody>
@@ -3980,11 +4144,11 @@
             <a:avLst/>
           </a:prstGeom>
           <a:solidFill>
-            <a:srgbClr val="0B0F19"/>
+            <a:srgbClr val="F8FAFC"/>
           </a:solidFill>
           <a:ln>
             <a:solidFill>
-              <a:srgbClr val="0B0F19"/>
+              <a:srgbClr val="F8FAFC"/>
             </a:solidFill>
           </a:ln>
         </p:spPr>
@@ -4019,7 +4183,7 @@
         <p:spPr>
           <a:xfrm>
             <a:off x="731520" y="365760"/>
-            <a:ext cx="10515600" cy="365760"/>
+            <a:ext cx="10698480" cy="320040"/>
           </a:xfrm>
           <a:prstGeom prst="rect">
             <a:avLst/>
@@ -4035,7 +4199,7 @@
             <a:pPr>
               <a:defRPr sz="1100" b="1">
                 <a:solidFill>
-                  <a:srgbClr val="818CF8"/>
+                  <a:srgbClr val="0284C7"/>
                 </a:solidFill>
               </a:defRPr>
             </a:pPr>
@@ -4053,8 +4217,8 @@
         </p:nvSpPr>
         <p:spPr>
           <a:xfrm>
-            <a:off x="731520" y="640080"/>
-            <a:ext cx="10515600" cy="640080"/>
+            <a:off x="731520" y="621792"/>
+            <a:ext cx="10698480" cy="640080"/>
           </a:xfrm>
           <a:prstGeom prst="rect">
             <a:avLst/>
@@ -4070,7 +4234,7 @@
             <a:pPr>
               <a:defRPr sz="2400" b="1">
                 <a:solidFill>
-                  <a:srgbClr val="F1F5F9"/>
+                  <a:srgbClr val="0F172A"/>
                 </a:solidFill>
               </a:defRPr>
             </a:pPr>
@@ -4088,18 +4252,18 @@
         </p:nvSpPr>
         <p:spPr>
           <a:xfrm>
-            <a:off x="731520" y="1325880"/>
-            <a:ext cx="10698480" cy="18288"/>
+            <a:off x="731520" y="1298448"/>
+            <a:ext cx="10698480" cy="27432"/>
           </a:xfrm>
           <a:prstGeom prst="rect">
             <a:avLst/>
           </a:prstGeom>
           <a:solidFill>
-            <a:srgbClr val="243354"/>
+            <a:srgbClr val="0284C7"/>
           </a:solidFill>
           <a:ln>
             <a:solidFill>
-              <a:srgbClr val="243354"/>
+              <a:srgbClr val="0284C7"/>
             </a:solidFill>
           </a:ln>
         </p:spPr>
@@ -4134,8 +4298,8 @@
           <p:nvPr/>
         </p:nvGraphicFramePr>
         <p:xfrm>
-          <a:off x="731520" y="1645920"/>
-          <a:ext cx="10698480" cy="4389120"/>
+          <a:off x="731520" y="1600200"/>
+          <a:ext cx="10698480" cy="4572000"/>
         </p:xfrm>
         <a:graphic>
           <a:graphicData uri="http://schemas.openxmlformats.org/drawingml/2006/table">
@@ -4148,16 +4312,16 @@
                 <a:gridCol w="4114800"/>
                 <a:gridCol w="3657600"/>
               </a:tblGrid>
-              <a:tr h="731520">
+              <a:tr h="762000">
                 <a:tc>
                   <a:txBody>
                     <a:bodyPr/>
                     <a:lstStyle/>
                     <a:p>
                       <a:pPr>
-                        <a:defRPr sz="1300" b="1">
+                        <a:defRPr sz="1200" b="1">
                           <a:solidFill>
-                            <a:srgbClr val="38BDF8"/>
+                            <a:srgbClr val="FFFFFF"/>
                           </a:solidFill>
                         </a:defRPr>
                       </a:pPr>
@@ -4168,7 +4332,7 @@
                   </a:txBody>
                   <a:tcPr>
                     <a:solidFill>
-                      <a:srgbClr val="1E293B"/>
+                      <a:srgbClr val="0284C7"/>
                     </a:solidFill>
                   </a:tcPr>
                 </a:tc>
@@ -4178,9 +4342,9 @@
                     <a:lstStyle/>
                     <a:p>
                       <a:pPr>
-                        <a:defRPr sz="1300" b="1">
+                        <a:defRPr sz="1200" b="1">
                           <a:solidFill>
-                            <a:srgbClr val="38BDF8"/>
+                            <a:srgbClr val="FFFFFF"/>
                           </a:solidFill>
                         </a:defRPr>
                       </a:pPr>
@@ -4191,7 +4355,7 @@
                   </a:txBody>
                   <a:tcPr>
                     <a:solidFill>
-                      <a:srgbClr val="1E293B"/>
+                      <a:srgbClr val="0284C7"/>
                     </a:solidFill>
                   </a:tcPr>
                 </a:tc>
@@ -4201,9 +4365,9 @@
                     <a:lstStyle/>
                     <a:p>
                       <a:pPr>
-                        <a:defRPr sz="1300" b="1">
+                        <a:defRPr sz="1200" b="1">
                           <a:solidFill>
-                            <a:srgbClr val="38BDF8"/>
+                            <a:srgbClr val="FFFFFF"/>
                           </a:solidFill>
                         </a:defRPr>
                       </a:pPr>
@@ -4214,12 +4378,12 @@
                   </a:txBody>
                   <a:tcPr>
                     <a:solidFill>
-                      <a:srgbClr val="1E293B"/>
+                      <a:srgbClr val="0284C7"/>
                     </a:solidFill>
                   </a:tcPr>
                 </a:tc>
               </a:tr>
-              <a:tr h="731520">
+              <a:tr h="762000">
                 <a:tc>
                   <a:txBody>
                     <a:bodyPr/>
@@ -4228,7 +4392,7 @@
                       <a:pPr>
                         <a:defRPr sz="1100">
                           <a:solidFill>
-                            <a:srgbClr val="F1F5F9"/>
+                            <a:srgbClr val="0F172A"/>
                           </a:solidFill>
                         </a:defRPr>
                       </a:pPr>
@@ -4239,7 +4403,7 @@
                   </a:txBody>
                   <a:tcPr>
                     <a:solidFill>
-                      <a:srgbClr val="151D30"/>
+                      <a:srgbClr val="FFFFFF"/>
                     </a:solidFill>
                   </a:tcPr>
                 </a:tc>
@@ -4251,7 +4415,7 @@
                       <a:pPr>
                         <a:defRPr sz="1100">
                           <a:solidFill>
-                            <a:srgbClr val="F1F5F9"/>
+                            <a:srgbClr val="0F172A"/>
                           </a:solidFill>
                         </a:defRPr>
                       </a:pPr>
@@ -4262,7 +4426,7 @@
                   </a:txBody>
                   <a:tcPr>
                     <a:solidFill>
-                      <a:srgbClr val="151D30"/>
+                      <a:srgbClr val="FFFFFF"/>
                     </a:solidFill>
                   </a:tcPr>
                 </a:tc>
@@ -4274,23 +4438,23 @@
                       <a:pPr>
                         <a:defRPr sz="1100">
                           <a:solidFill>
-                            <a:srgbClr val="F1F5F9"/>
+                            <a:srgbClr val="0F172A"/>
                           </a:solidFill>
                         </a:defRPr>
                       </a:pPr>
                       <a:r>
-                        <a:t>clone() with isolated stack, waitpid(), custom PCB</a:t>
+                        <a:t>clone() with isolated stack, waitpid(), custom PCB handling</a:t>
                       </a:r>
                     </a:p>
                   </a:txBody>
                   <a:tcPr>
                     <a:solidFill>
-                      <a:srgbClr val="151D30"/>
+                      <a:srgbClr val="FFFFFF"/>
                     </a:solidFill>
                   </a:tcPr>
                 </a:tc>
               </a:tr>
-              <a:tr h="731520">
+              <a:tr h="762000">
                 <a:tc>
                   <a:txBody>
                     <a:bodyPr/>
@@ -4299,7 +4463,7 @@
                       <a:pPr>
                         <a:defRPr sz="1100">
                           <a:solidFill>
-                            <a:srgbClr val="F1F5F9"/>
+                            <a:srgbClr val="0F172A"/>
                           </a:solidFill>
                         </a:defRPr>
                       </a:pPr>
@@ -4310,7 +4474,7 @@
                   </a:txBody>
                   <a:tcPr>
                     <a:solidFill>
-                      <a:srgbClr val="151D30"/>
+                      <a:srgbClr val="F1F5F9"/>
                     </a:solidFill>
                   </a:tcPr>
                 </a:tc>
@@ -4322,7 +4486,7 @@
                       <a:pPr>
                         <a:defRPr sz="1100">
                           <a:solidFill>
-                            <a:srgbClr val="F1F5F9"/>
+                            <a:srgbClr val="0F172A"/>
                           </a:solidFill>
                         </a:defRPr>
                       </a:pPr>
@@ -4333,7 +4497,7 @@
                   </a:txBody>
                   <a:tcPr>
                     <a:solidFill>
-                      <a:srgbClr val="151D30"/>
+                      <a:srgbClr val="F1F5F9"/>
                     </a:solidFill>
                   </a:tcPr>
                 </a:tc>
@@ -4345,7 +4509,7 @@
                       <a:pPr>
                         <a:defRPr sz="1100">
                           <a:solidFill>
-                            <a:srgbClr val="F1F5F9"/>
+                            <a:srgbClr val="0F172A"/>
                           </a:solidFill>
                         </a:defRPr>
                       </a:pPr>
@@ -4356,12 +4520,12 @@
                   </a:txBody>
                   <a:tcPr>
                     <a:solidFill>
-                      <a:srgbClr val="151D30"/>
+                      <a:srgbClr val="F1F5F9"/>
                     </a:solidFill>
                   </a:tcPr>
                 </a:tc>
               </a:tr>
-              <a:tr h="731520">
+              <a:tr h="762000">
                 <a:tc>
                   <a:txBody>
                     <a:bodyPr/>
@@ -4370,7 +4534,7 @@
                       <a:pPr>
                         <a:defRPr sz="1100">
                           <a:solidFill>
-                            <a:srgbClr val="F1F5F9"/>
+                            <a:srgbClr val="0F172A"/>
                           </a:solidFill>
                         </a:defRPr>
                       </a:pPr>
@@ -4381,7 +4545,7 @@
                   </a:txBody>
                   <a:tcPr>
                     <a:solidFill>
-                      <a:srgbClr val="151D30"/>
+                      <a:srgbClr val="FFFFFF"/>
                     </a:solidFill>
                   </a:tcPr>
                 </a:tc>
@@ -4393,7 +4557,7 @@
                       <a:pPr>
                         <a:defRPr sz="1100">
                           <a:solidFill>
-                            <a:srgbClr val="F1F5F9"/>
+                            <a:srgbClr val="0F172A"/>
                           </a:solidFill>
                         </a:defRPr>
                       </a:pPr>
@@ -4404,7 +4568,7 @@
                   </a:txBody>
                   <a:tcPr>
                     <a:solidFill>
-                      <a:srgbClr val="151D30"/>
+                      <a:srgbClr val="FFFFFF"/>
                     </a:solidFill>
                   </a:tcPr>
                 </a:tc>
@@ -4416,7 +4580,7 @@
                       <a:pPr>
                         <a:defRPr sz="1100">
                           <a:solidFill>
-                            <a:srgbClr val="F1F5F9"/>
+                            <a:srgbClr val="0F172A"/>
                           </a:solidFill>
                         </a:defRPr>
                       </a:pPr>
@@ -4427,12 +4591,12 @@
                   </a:txBody>
                   <a:tcPr>
                     <a:solidFill>
-                      <a:srgbClr val="151D30"/>
+                      <a:srgbClr val="FFFFFF"/>
                     </a:solidFill>
                   </a:tcPr>
                 </a:tc>
               </a:tr>
-              <a:tr h="731520">
+              <a:tr h="762000">
                 <a:tc>
                   <a:txBody>
                     <a:bodyPr/>
@@ -4441,7 +4605,7 @@
                       <a:pPr>
                         <a:defRPr sz="1100">
                           <a:solidFill>
-                            <a:srgbClr val="F1F5F9"/>
+                            <a:srgbClr val="0F172A"/>
                           </a:solidFill>
                         </a:defRPr>
                       </a:pPr>
@@ -4452,7 +4616,7 @@
                   </a:txBody>
                   <a:tcPr>
                     <a:solidFill>
-                      <a:srgbClr val="151D30"/>
+                      <a:srgbClr val="F1F5F9"/>
                     </a:solidFill>
                   </a:tcPr>
                 </a:tc>
@@ -4464,7 +4628,7 @@
                       <a:pPr>
                         <a:defRPr sz="1100">
                           <a:solidFill>
-                            <a:srgbClr val="F1F5F9"/>
+                            <a:srgbClr val="0F172A"/>
                           </a:solidFill>
                         </a:defRPr>
                       </a:pPr>
@@ -4475,7 +4639,7 @@
                   </a:txBody>
                   <a:tcPr>
                     <a:solidFill>
-                      <a:srgbClr val="151D30"/>
+                      <a:srgbClr val="F1F5F9"/>
                     </a:solidFill>
                   </a:tcPr>
                 </a:tc>
@@ -4487,7 +4651,7 @@
                       <a:pPr>
                         <a:defRPr sz="1100">
                           <a:solidFill>
-                            <a:srgbClr val="F1F5F9"/>
+                            <a:srgbClr val="0F172A"/>
                           </a:solidFill>
                         </a:defRPr>
                       </a:pPr>
@@ -4498,12 +4662,12 @@
                   </a:txBody>
                   <a:tcPr>
                     <a:solidFill>
-                      <a:srgbClr val="151D30"/>
+                      <a:srgbClr val="F1F5F9"/>
                     </a:solidFill>
                   </a:tcPr>
                 </a:tc>
               </a:tr>
-              <a:tr h="731520">
+              <a:tr h="762000">
                 <a:tc>
                   <a:txBody>
                     <a:bodyPr/>
@@ -4512,7 +4676,7 @@
                       <a:pPr>
                         <a:defRPr sz="1100">
                           <a:solidFill>
-                            <a:srgbClr val="F1F5F9"/>
+                            <a:srgbClr val="0F172A"/>
                           </a:solidFill>
                         </a:defRPr>
                       </a:pPr>
@@ -4523,7 +4687,7 @@
                   </a:txBody>
                   <a:tcPr>
                     <a:solidFill>
-                      <a:srgbClr val="151D30"/>
+                      <a:srgbClr val="FFFFFF"/>
                     </a:solidFill>
                   </a:tcPr>
                 </a:tc>
@@ -4535,7 +4699,7 @@
                       <a:pPr>
                         <a:defRPr sz="1100">
                           <a:solidFill>
-                            <a:srgbClr val="F1F5F9"/>
+                            <a:srgbClr val="0F172A"/>
                           </a:solidFill>
                         </a:defRPr>
                       </a:pPr>
@@ -4546,7 +4710,7 @@
                   </a:txBody>
                   <a:tcPr>
                     <a:solidFill>
-                      <a:srgbClr val="151D30"/>
+                      <a:srgbClr val="FFFFFF"/>
                     </a:solidFill>
                   </a:tcPr>
                 </a:tc>
@@ -4558,7 +4722,7 @@
                       <a:pPr>
                         <a:defRPr sz="1100">
                           <a:solidFill>
-                            <a:srgbClr val="F1F5F9"/>
+                            <a:srgbClr val="0F172A"/>
                           </a:solidFill>
                         </a:defRPr>
                       </a:pPr>
@@ -4569,7 +4733,7 @@
                   </a:txBody>
                   <a:tcPr>
                     <a:solidFill>
-                      <a:srgbClr val="151D30"/>
+                      <a:srgbClr val="FFFFFF"/>
                     </a:solidFill>
                   </a:tcPr>
                 </a:tc>
@@ -4611,11 +4775,11 @@
             <a:avLst/>
           </a:prstGeom>
           <a:solidFill>
-            <a:srgbClr val="0B0F19"/>
+            <a:srgbClr val="F8FAFC"/>
           </a:solidFill>
           <a:ln>
             <a:solidFill>
-              <a:srgbClr val="0B0F19"/>
+              <a:srgbClr val="F8FAFC"/>
             </a:solidFill>
           </a:ln>
         </p:spPr>
@@ -4650,7 +4814,7 @@
         <p:spPr>
           <a:xfrm>
             <a:off x="731520" y="365760"/>
-            <a:ext cx="10515600" cy="365760"/>
+            <a:ext cx="10698480" cy="320040"/>
           </a:xfrm>
           <a:prstGeom prst="rect">
             <a:avLst/>
@@ -4666,12 +4830,12 @@
             <a:pPr>
               <a:defRPr sz="1100" b="1">
                 <a:solidFill>
-                  <a:srgbClr val="818CF8"/>
-                </a:solidFill>
-              </a:defRPr>
-            </a:pPr>
-            <a:r>
-              <a:t>PROCESS LIFECYCLE</a:t>
+                  <a:srgbClr val="0284C7"/>
+                </a:solidFill>
+              </a:defRPr>
+            </a:pPr>
+            <a:r>
+              <a:t>PROCESS LIFECYCLE FLOW</a:t>
             </a:r>
           </a:p>
         </p:txBody>
@@ -4684,8 +4848,8 @@
         </p:nvSpPr>
         <p:spPr>
           <a:xfrm>
-            <a:off x="731520" y="640080"/>
-            <a:ext cx="10515600" cy="640080"/>
+            <a:off x="731520" y="621792"/>
+            <a:ext cx="10698480" cy="640080"/>
           </a:xfrm>
           <a:prstGeom prst="rect">
             <a:avLst/>
@@ -4701,12 +4865,12 @@
             <a:pPr>
               <a:defRPr sz="2400" b="1">
                 <a:solidFill>
-                  <a:srgbClr val="F1F5F9"/>
-                </a:solidFill>
-              </a:defRPr>
-            </a:pPr>
-            <a:r>
-              <a:t>System Architecture &amp; Execution Flow</a:t>
+                  <a:srgbClr val="0F172A"/>
+                </a:solidFill>
+              </a:defRPr>
+            </a:pPr>
+            <a:r>
+              <a:t>System Architecture &amp; Execution Lifecycle</a:t>
             </a:r>
           </a:p>
         </p:txBody>
@@ -4719,18 +4883,18 @@
         </p:nvSpPr>
         <p:spPr>
           <a:xfrm>
-            <a:off x="731520" y="1325880"/>
-            <a:ext cx="10698480" cy="18288"/>
+            <a:off x="731520" y="1298448"/>
+            <a:ext cx="10698480" cy="27432"/>
           </a:xfrm>
           <a:prstGeom prst="rect">
             <a:avLst/>
           </a:prstGeom>
           <a:solidFill>
-            <a:srgbClr val="243354"/>
+            <a:srgbClr val="0284C7"/>
           </a:solidFill>
           <a:ln>
             <a:solidFill>
-              <a:srgbClr val="243354"/>
+              <a:srgbClr val="0284C7"/>
             </a:solidFill>
           </a:ln>
         </p:spPr>
@@ -4764,18 +4928,18 @@
         </p:nvSpPr>
         <p:spPr>
           <a:xfrm>
-            <a:off x="731520" y="1645920"/>
-            <a:ext cx="5120640" cy="4480560"/>
+            <a:off x="731520" y="1600200"/>
+            <a:ext cx="5120640" cy="4663440"/>
           </a:xfrm>
           <a:prstGeom prst="roundRect">
             <a:avLst/>
           </a:prstGeom>
           <a:solidFill>
-            <a:srgbClr val="151D30"/>
+            <a:srgbClr val="FFFFFF"/>
           </a:solidFill>
           <a:ln w="19050">
             <a:solidFill>
-              <a:srgbClr val="243354"/>
+              <a:srgbClr val="CBD5E1"/>
             </a:solidFill>
           </a:ln>
         </p:spPr>
@@ -4803,182 +4967,24 @@
       </p:sp>
       <p:sp>
         <p:nvSpPr>
-          <p:cNvPr id="7" name="TextBox 6"/>
-          <p:cNvSpPr txBox="1"/>
-          <p:nvPr/>
-        </p:nvSpPr>
-        <p:spPr>
-          <a:xfrm>
-            <a:off x="914400" y="1828800"/>
-            <a:ext cx="4754880" cy="4114800"/>
-          </a:xfrm>
-          <a:prstGeom prst="rect">
-            <a:avLst/>
-          </a:prstGeom>
-          <a:noFill/>
-        </p:spPr>
-        <p:txBody>
-          <a:bodyPr wrap="square">
-            <a:spAutoFit/>
-          </a:bodyPr>
-          <a:lstStyle/>
-          <a:p>
-            <a:pPr>
-              <a:spcAft>
-                <a:spcPts val="1000"/>
-              </a:spcAft>
-              <a:defRPr sz="1600" b="1">
-                <a:solidFill>
-                  <a:srgbClr val="38BDF8"/>
-                </a:solidFill>
-              </a:defRPr>
-            </a:pPr>
-            <a:r>
-              <a:t>Execution Lifecycle Flow</a:t>
-            </a:r>
-          </a:p>
-          <a:p>
-            <a:pPr>
-              <a:spcAft>
-                <a:spcPts val="800"/>
-              </a:spcAft>
-              <a:defRPr sz="1300">
-                <a:solidFill>
-                  <a:srgbClr val="F1F5F9"/>
-                </a:solidFill>
-              </a:defRPr>
-            </a:pPr>
-            <a:r>
-              <a:t>•  1. CLI Invocation: Parses arguments (--memory, --cpu, --pids, etc.)</a:t>
-            </a:r>
-          </a:p>
-          <a:p>
-            <a:pPr>
-              <a:spcAft>
-                <a:spcPts val="800"/>
-              </a:spcAft>
-              <a:defRPr sz="1300">
-                <a:solidFill>
-                  <a:srgbClr val="F1F5F9"/>
-                </a:solidFill>
-              </a:defRPr>
-            </a:pPr>
-            <a:r>
-              <a:t>•  2. Host Parent: Allocates 1MB stack &amp; creates POSIX sync pipe.</a:t>
-            </a:r>
-          </a:p>
-          <a:p>
-            <a:pPr>
-              <a:spcAft>
-                <a:spcPts val="800"/>
-              </a:spcAft>
-              <a:defRPr sz="1300">
-                <a:solidFill>
-                  <a:srgbClr val="F1F5F9"/>
-                </a:solidFill>
-              </a:defRPr>
-            </a:pPr>
-            <a:r>
-              <a:t>•  3. clone() Syscall: Dispatches child with CLONE_NEW* namespace flags.</a:t>
-            </a:r>
-          </a:p>
-          <a:p>
-            <a:pPr>
-              <a:spcAft>
-                <a:spcPts val="800"/>
-              </a:spcAft>
-              <a:defRPr sz="1300">
-                <a:solidFill>
-                  <a:srgbClr val="F1F5F9"/>
-                </a:solidFill>
-              </a:defRPr>
-            </a:pPr>
-            <a:r>
-              <a:t>•  4. Cgroups Binding: Parent creates /sys/fs/cgroup/minicontainer-[PID].</a:t>
-            </a:r>
-          </a:p>
-          <a:p>
-            <a:pPr>
-              <a:spcAft>
-                <a:spcPts val="800"/>
-              </a:spcAft>
-              <a:defRPr sz="1300">
-                <a:solidFill>
-                  <a:srgbClr val="F1F5F9"/>
-                </a:solidFill>
-              </a:defRPr>
-            </a:pPr>
-            <a:r>
-              <a:t>•  5. Sync Barrier: Parent signals child via pipe (eliminates race condition).</a:t>
-            </a:r>
-          </a:p>
-          <a:p>
-            <a:pPr>
-              <a:spcAft>
-                <a:spcPts val="800"/>
-              </a:spcAft>
-              <a:defRPr sz="1300">
-                <a:solidFill>
-                  <a:srgbClr val="F1F5F9"/>
-                </a:solidFill>
-              </a:defRPr>
-            </a:pPr>
-            <a:r>
-              <a:t>•  6. Sandbox Init: Child sethostname(), chroot(), mounts private /proc.</a:t>
-            </a:r>
-          </a:p>
-          <a:p>
-            <a:pPr>
-              <a:spcAft>
-                <a:spcPts val="800"/>
-              </a:spcAft>
-              <a:defRPr sz="1300">
-                <a:solidFill>
-                  <a:srgbClr val="F1F5F9"/>
-                </a:solidFill>
-              </a:defRPr>
-            </a:pPr>
-            <a:r>
-              <a:t>•  7. Execution: Child calls execvp(), becomes PID 1 inside container.</a:t>
-            </a:r>
-          </a:p>
-          <a:p>
-            <a:pPr>
-              <a:spcAft>
-                <a:spcPts val="800"/>
-              </a:spcAft>
-              <a:defRPr sz="1300">
-                <a:solidFill>
-                  <a:srgbClr val="F1F5F9"/>
-                </a:solidFill>
-              </a:defRPr>
-            </a:pPr>
-            <a:r>
-              <a:t>•  8. Teardown: Parent waitpid() catches exit/OOM kill, cleans cgroups.</a:t>
-            </a:r>
-          </a:p>
-        </p:txBody>
-      </p:sp>
-      <p:sp>
-        <p:nvSpPr>
-          <p:cNvPr id="8" name="Rounded Rectangle 7"/>
+          <p:cNvPr id="7" name="Rounded Rectangle 6"/>
           <p:cNvSpPr/>
           <p:nvPr/>
         </p:nvSpPr>
         <p:spPr>
           <a:xfrm>
-            <a:off x="6217920" y="1645920"/>
-            <a:ext cx="5120640" cy="4480560"/>
+            <a:off x="749808" y="1618488"/>
+            <a:ext cx="5084064" cy="91440"/>
           </a:xfrm>
           <a:prstGeom prst="roundRect">
             <a:avLst/>
           </a:prstGeom>
           <a:solidFill>
-            <a:srgbClr val="151D30"/>
+            <a:srgbClr val="0284C7"/>
           </a:solidFill>
-          <a:ln w="19050">
+          <a:ln>
             <a:solidFill>
-              <a:srgbClr val="243354"/>
+              <a:srgbClr val="0284C7"/>
             </a:solidFill>
           </a:ln>
         </p:spPr>
@@ -5006,14 +5012,14 @@
       </p:sp>
       <p:sp>
         <p:nvSpPr>
-          <p:cNvPr id="9" name="TextBox 8"/>
+          <p:cNvPr id="8" name="TextBox 7"/>
           <p:cNvSpPr txBox="1"/>
           <p:nvPr/>
         </p:nvSpPr>
         <p:spPr>
           <a:xfrm>
-            <a:off x="6400800" y="1828800"/>
-            <a:ext cx="4754880" cy="4114800"/>
+            <a:off x="960120" y="1801368"/>
+            <a:ext cx="4663440" cy="4343400"/>
           </a:xfrm>
           <a:prstGeom prst="rect">
             <a:avLst/>
@@ -5028,76 +5034,339 @@
           <a:p>
             <a:pPr>
               <a:spcAft>
-                <a:spcPts val="1000"/>
+                <a:spcPts val="800"/>
               </a:spcAft>
-              <a:defRPr sz="1600" b="1">
-                <a:solidFill>
-                  <a:srgbClr val="818CF8"/>
-                </a:solidFill>
-              </a:defRPr>
-            </a:pPr>
-            <a:r>
-              <a:t>Key Engineering Highlights</a:t>
-            </a:r>
-          </a:p>
+              <a:defRPr sz="1500" b="1">
+                <a:solidFill>
+                  <a:srgbClr val="0284C7"/>
+                </a:solidFill>
+              </a:defRPr>
+            </a:pPr>
+            <a:r>
+              <a:t>Coordinated Execution Pipeline</a:t>
+            </a:r>
+          </a:p>
+          <a:p>
+            <a:pPr>
+              <a:spcAft>
+                <a:spcPts val="600"/>
+              </a:spcAft>
+              <a:defRPr sz="1200">
+                <a:solidFill>
+                  <a:srgbClr val="0F172A"/>
+                </a:solidFill>
+              </a:defRPr>
+            </a:pPr>
+            <a:r>
+              <a:t>•  1. CLI Parsing: Processes flags (--memory 30M, --cpu 40, --pids 10).</a:t>
+            </a:r>
+          </a:p>
+          <a:p>
+            <a:pPr>
+              <a:spcAft>
+                <a:spcPts val="600"/>
+              </a:spcAft>
+              <a:defRPr sz="1200">
+                <a:solidFill>
+                  <a:srgbClr val="0F172A"/>
+                </a:solidFill>
+              </a:defRPr>
+            </a:pPr>
+            <a:r>
+              <a:t>•  2. Child Stack Allocation: 1MB isolated stack allocated via malloc().</a:t>
+            </a:r>
+          </a:p>
+          <a:p>
+            <a:pPr>
+              <a:spcAft>
+                <a:spcPts val="600"/>
+              </a:spcAft>
+              <a:defRPr sz="1200">
+                <a:solidFill>
+                  <a:srgbClr val="0F172A"/>
+                </a:solidFill>
+              </a:defRPr>
+            </a:pPr>
+            <a:r>
+              <a:t>•  3. POSIX Sync Pipe: pipe(sync_pipe) opened to eliminate race conditions.</a:t>
+            </a:r>
+          </a:p>
+          <a:p>
+            <a:pPr>
+              <a:spcAft>
+                <a:spcPts val="600"/>
+              </a:spcAft>
+              <a:defRPr sz="1200">
+                <a:solidFill>
+                  <a:srgbClr val="0F172A"/>
+                </a:solidFill>
+              </a:defRPr>
+            </a:pPr>
+            <a:r>
+              <a:t>•  4. clone() Syscall: Dispatches child with CLONE_NEW* namespace flags.</a:t>
+            </a:r>
+          </a:p>
+          <a:p>
+            <a:pPr>
+              <a:spcAft>
+                <a:spcPts val="600"/>
+              </a:spcAft>
+              <a:defRPr sz="1200">
+                <a:solidFill>
+                  <a:srgbClr val="0F172A"/>
+                </a:solidFill>
+              </a:defRPr>
+            </a:pPr>
+            <a:r>
+              <a:t>•  5. Cgroups Attachment: Parent writes child PID to cgroup.procs.</a:t>
+            </a:r>
+          </a:p>
+          <a:p>
+            <a:pPr>
+              <a:spcAft>
+                <a:spcPts val="600"/>
+              </a:spcAft>
+              <a:defRPr sz="1200">
+                <a:solidFill>
+                  <a:srgbClr val="0F172A"/>
+                </a:solidFill>
+              </a:defRPr>
+            </a:pPr>
+            <a:r>
+              <a:t>•  6. Controller Envelopes: Sets memory.max, cpu.max, and pids.max.</a:t>
+            </a:r>
+          </a:p>
+          <a:p>
+            <a:pPr>
+              <a:spcAft>
+                <a:spcPts val="600"/>
+              </a:spcAft>
+              <a:defRPr sz="1200">
+                <a:solidFill>
+                  <a:srgbClr val="0F172A"/>
+                </a:solidFill>
+              </a:defRPr>
+            </a:pPr>
+            <a:r>
+              <a:t>•  7. Handshake Signal: Parent writes trigger byte to unblock child.</a:t>
+            </a:r>
+          </a:p>
+          <a:p>
+            <a:pPr>
+              <a:spcAft>
+                <a:spcPts val="600"/>
+              </a:spcAft>
+              <a:defRPr sz="1200">
+                <a:solidFill>
+                  <a:srgbClr val="0F172A"/>
+                </a:solidFill>
+              </a:defRPr>
+            </a:pPr>
+            <a:r>
+              <a:t>•  8. Sandbox Execution: Child sets hostname, chroot(), execvp().</a:t>
+            </a:r>
+          </a:p>
+          <a:p>
+            <a:pPr>
+              <a:spcAft>
+                <a:spcPts val="600"/>
+              </a:spcAft>
+              <a:defRPr sz="1200">
+                <a:solidFill>
+                  <a:srgbClr val="0F172A"/>
+                </a:solidFill>
+              </a:defRPr>
+            </a:pPr>
+            <a:r>
+              <a:t>•  9. Post-Execution Accounting: Reads memory.stat, logs page faults.</a:t>
+            </a:r>
+          </a:p>
+        </p:txBody>
+      </p:sp>
+      <p:sp>
+        <p:nvSpPr>
+          <p:cNvPr id="9" name="Rounded Rectangle 8"/>
+          <p:cNvSpPr/>
+          <p:nvPr/>
+        </p:nvSpPr>
+        <p:spPr>
+          <a:xfrm>
+            <a:off x="6217920" y="1600200"/>
+            <a:ext cx="5120640" cy="4663440"/>
+          </a:xfrm>
+          <a:prstGeom prst="roundRect">
+            <a:avLst/>
+          </a:prstGeom>
+          <a:solidFill>
+            <a:srgbClr val="FFFFFF"/>
+          </a:solidFill>
+          <a:ln w="19050">
+            <a:solidFill>
+              <a:srgbClr val="CBD5E1"/>
+            </a:solidFill>
+          </a:ln>
+        </p:spPr>
+        <p:style>
+          <a:lnRef idx="1">
+            <a:schemeClr val="accent1"/>
+          </a:lnRef>
+          <a:fillRef idx="3">
+            <a:schemeClr val="accent1"/>
+          </a:fillRef>
+          <a:effectRef idx="2">
+            <a:schemeClr val="accent1"/>
+          </a:effectRef>
+          <a:fontRef idx="minor">
+            <a:schemeClr val="lt1"/>
+          </a:fontRef>
+        </p:style>
+        <p:txBody>
+          <a:bodyPr rtlCol="0" anchor="ctr"/>
+          <a:lstStyle/>
+          <a:p>
+            <a:pPr algn="ctr"/>
+          </a:p>
+        </p:txBody>
+      </p:sp>
+      <p:sp>
+        <p:nvSpPr>
+          <p:cNvPr id="10" name="Rounded Rectangle 9"/>
+          <p:cNvSpPr/>
+          <p:nvPr/>
+        </p:nvSpPr>
+        <p:spPr>
+          <a:xfrm>
+            <a:off x="6236208" y="1618488"/>
+            <a:ext cx="5084064" cy="91440"/>
+          </a:xfrm>
+          <a:prstGeom prst="roundRect">
+            <a:avLst/>
+          </a:prstGeom>
+          <a:solidFill>
+            <a:srgbClr val="4F46E5"/>
+          </a:solidFill>
+          <a:ln>
+            <a:solidFill>
+              <a:srgbClr val="4F46E5"/>
+            </a:solidFill>
+          </a:ln>
+        </p:spPr>
+        <p:style>
+          <a:lnRef idx="1">
+            <a:schemeClr val="accent1"/>
+          </a:lnRef>
+          <a:fillRef idx="3">
+            <a:schemeClr val="accent1"/>
+          </a:fillRef>
+          <a:effectRef idx="2">
+            <a:schemeClr val="accent1"/>
+          </a:effectRef>
+          <a:fontRef idx="minor">
+            <a:schemeClr val="lt1"/>
+          </a:fontRef>
+        </p:style>
+        <p:txBody>
+          <a:bodyPr rtlCol="0" anchor="ctr"/>
+          <a:lstStyle/>
+          <a:p>
+            <a:pPr algn="ctr"/>
+          </a:p>
+        </p:txBody>
+      </p:sp>
+      <p:sp>
+        <p:nvSpPr>
+          <p:cNvPr id="11" name="TextBox 10"/>
+          <p:cNvSpPr txBox="1"/>
+          <p:nvPr/>
+        </p:nvSpPr>
+        <p:spPr>
+          <a:xfrm>
+            <a:off x="6446520" y="1801368"/>
+            <a:ext cx="4663440" cy="4343400"/>
+          </a:xfrm>
+          <a:prstGeom prst="rect">
+            <a:avLst/>
+          </a:prstGeom>
+          <a:noFill/>
+        </p:spPr>
+        <p:txBody>
+          <a:bodyPr wrap="square">
+            <a:spAutoFit/>
+          </a:bodyPr>
+          <a:lstStyle/>
           <a:p>
             <a:pPr>
               <a:spcAft>
                 <a:spcPts val="800"/>
               </a:spcAft>
-              <a:defRPr sz="1300">
-                <a:solidFill>
-                  <a:srgbClr val="F1F5F9"/>
-                </a:solidFill>
-              </a:defRPr>
-            </a:pPr>
-            <a:r>
-              <a:t>•  Race-Free Attachment: Child blocks on pipe until parent establishes cgroup limits, preventing unconstrained child execution.</a:t>
+              <a:defRPr sz="1500" b="1">
+                <a:solidFill>
+                  <a:srgbClr val="4F46E5"/>
+                </a:solidFill>
+              </a:defRPr>
+            </a:pPr>
+            <a:r>
+              <a:t>Architectural Safety Guarantees</a:t>
             </a:r>
           </a:p>
           <a:p>
             <a:pPr>
               <a:spcAft>
-                <a:spcPts val="800"/>
+                <a:spcPts val="600"/>
               </a:spcAft>
-              <a:defRPr sz="1300">
-                <a:solidFill>
-                  <a:srgbClr val="F1F5F9"/>
-                </a:solidFill>
-              </a:defRPr>
-            </a:pPr>
-            <a:r>
-              <a:t>•  VFS Isolation: Mount propagation set to MS_PRIVATE to prevent container mount events from leaking into the host OS.</a:t>
+              <a:defRPr sz="1200">
+                <a:solidFill>
+                  <a:srgbClr val="0F172A"/>
+                </a:solidFill>
+              </a:defRPr>
+            </a:pPr>
+            <a:r>
+              <a:t>•  Barrier Synchronization: The child process pauses on read(pipe[0]) until the parent confirms cgroup bounds are active.</a:t>
             </a:r>
           </a:p>
           <a:p>
             <a:pPr>
               <a:spcAft>
-                <a:spcPts val="800"/>
+                <a:spcPts val="600"/>
               </a:spcAft>
-              <a:defRPr sz="1300">
-                <a:solidFill>
-                  <a:srgbClr val="F1F5F9"/>
-                </a:solidFill>
-              </a:defRPr>
-            </a:pPr>
-            <a:r>
-              <a:t>•  Kernel Accounting: Reads memory.stat upon exit to capture peak RAM, minor page faults, and major page faults.</a:t>
+              <a:defRPr sz="1200">
+                <a:solidFill>
+                  <a:srgbClr val="0F172A"/>
+                </a:solidFill>
+              </a:defRPr>
+            </a:pPr>
+            <a:r>
+              <a:t>•  Mount Privacy (MS_PRIVATE): Prevents container mounts (/proc, rootfs) from leaking into the host operating system.</a:t>
             </a:r>
           </a:p>
           <a:p>
             <a:pPr>
               <a:spcAft>
-                <a:spcPts val="800"/>
+                <a:spcPts val="600"/>
               </a:spcAft>
-              <a:defRPr sz="1300">
-                <a:solidFill>
-                  <a:srgbClr val="F1F5F9"/>
-                </a:solidFill>
-              </a:defRPr>
-            </a:pPr>
-            <a:r>
-              <a:t>•  Zero-Dependency: Written entirely in C99 with native POSIX syscalls; runs on any standard Linux kernel 5.x/6.x.</a:t>
+              <a:defRPr sz="1200">
+                <a:solidFill>
+                  <a:srgbClr val="0F172A"/>
+                </a:solidFill>
+              </a:defRPr>
+            </a:pPr>
+            <a:r>
+              <a:t>•  Automated Resource Reclamation: Parent captures termination signals (OOM SIGKILL) via waitpid() and removes temporary cgroups.</a:t>
+            </a:r>
+          </a:p>
+          <a:p>
+            <a:pPr>
+              <a:spcAft>
+                <a:spcPts val="600"/>
+              </a:spcAft>
+              <a:defRPr sz="1200">
+                <a:solidFill>
+                  <a:srgbClr val="0F172A"/>
+                </a:solidFill>
+              </a:defRPr>
+            </a:pPr>
+            <a:r>
+              <a:t>•  Zero-Dependency Engineering: Built with pure C99 and native Linux system calls without third-party runtime frameworks.</a:t>
             </a:r>
           </a:p>
         </p:txBody>
@@ -5135,11 +5404,11 @@
             <a:avLst/>
           </a:prstGeom>
           <a:solidFill>
-            <a:srgbClr val="0B0F19"/>
+            <a:srgbClr val="F8FAFC"/>
           </a:solidFill>
           <a:ln>
             <a:solidFill>
-              <a:srgbClr val="0B0F19"/>
+              <a:srgbClr val="F8FAFC"/>
             </a:solidFill>
           </a:ln>
         </p:spPr>
@@ -5174,7 +5443,7 @@
         <p:spPr>
           <a:xfrm>
             <a:off x="731520" y="365760"/>
-            <a:ext cx="10515600" cy="365760"/>
+            <a:ext cx="10698480" cy="320040"/>
           </a:xfrm>
           <a:prstGeom prst="rect">
             <a:avLst/>
@@ -5190,7 +5459,7 @@
             <a:pPr>
               <a:defRPr sz="1100" b="1">
                 <a:solidFill>
-                  <a:srgbClr val="818CF8"/>
+                  <a:srgbClr val="0284C7"/>
                 </a:solidFill>
               </a:defRPr>
             </a:pPr>
@@ -5208,8 +5477,8 @@
         </p:nvSpPr>
         <p:spPr>
           <a:xfrm>
-            <a:off x="731520" y="640080"/>
-            <a:ext cx="10515600" cy="640080"/>
+            <a:off x="731520" y="621792"/>
+            <a:ext cx="10698480" cy="640080"/>
           </a:xfrm>
           <a:prstGeom prst="rect">
             <a:avLst/>
@@ -5225,12 +5494,12 @@
             <a:pPr>
               <a:defRPr sz="2400" b="1">
                 <a:solidFill>
-                  <a:srgbClr val="F1F5F9"/>
-                </a:solidFill>
-              </a:defRPr>
-            </a:pPr>
-            <a:r>
-              <a:t>Core Isolation Primitives in Linux</a:t>
+                  <a:srgbClr val="0F172A"/>
+                </a:solidFill>
+              </a:defRPr>
+            </a:pPr>
+            <a:r>
+              <a:t>Core Isolation Subsystems: The Three Pillars</a:t>
             </a:r>
           </a:p>
         </p:txBody>
@@ -5243,18 +5512,18 @@
         </p:nvSpPr>
         <p:spPr>
           <a:xfrm>
-            <a:off x="731520" y="1325880"/>
-            <a:ext cx="10698480" cy="18288"/>
+            <a:off x="731520" y="1298448"/>
+            <a:ext cx="10698480" cy="27432"/>
           </a:xfrm>
           <a:prstGeom prst="rect">
             <a:avLst/>
           </a:prstGeom>
           <a:solidFill>
-            <a:srgbClr val="243354"/>
+            <a:srgbClr val="0284C7"/>
           </a:solidFill>
           <a:ln>
             <a:solidFill>
-              <a:srgbClr val="243354"/>
+              <a:srgbClr val="0284C7"/>
             </a:solidFill>
           </a:ln>
         </p:spPr>
@@ -5288,18 +5557,18 @@
         </p:nvSpPr>
         <p:spPr>
           <a:xfrm>
-            <a:off x="731520" y="1645920"/>
-            <a:ext cx="3383280" cy="4480560"/>
+            <a:off x="731520" y="1600200"/>
+            <a:ext cx="3383280" cy="4663440"/>
           </a:xfrm>
           <a:prstGeom prst="roundRect">
             <a:avLst/>
           </a:prstGeom>
           <a:solidFill>
-            <a:srgbClr val="151D30"/>
+            <a:srgbClr val="FFFFFF"/>
           </a:solidFill>
           <a:ln w="19050">
             <a:solidFill>
-              <a:srgbClr val="243354"/>
+              <a:srgbClr val="CBD5E1"/>
             </a:solidFill>
           </a:ln>
         </p:spPr>
@@ -5327,137 +5596,24 @@
       </p:sp>
       <p:sp>
         <p:nvSpPr>
-          <p:cNvPr id="7" name="TextBox 6"/>
-          <p:cNvSpPr txBox="1"/>
-          <p:nvPr/>
-        </p:nvSpPr>
-        <p:spPr>
-          <a:xfrm>
-            <a:off x="914400" y="1828800"/>
-            <a:ext cx="3017520" cy="4114800"/>
-          </a:xfrm>
-          <a:prstGeom prst="rect">
-            <a:avLst/>
-          </a:prstGeom>
-          <a:noFill/>
-        </p:spPr>
-        <p:txBody>
-          <a:bodyPr wrap="square">
-            <a:spAutoFit/>
-          </a:bodyPr>
-          <a:lstStyle/>
-          <a:p>
-            <a:pPr>
-              <a:spcAft>
-                <a:spcPts val="1000"/>
-              </a:spcAft>
-              <a:defRPr sz="1600" b="1">
-                <a:solidFill>
-                  <a:srgbClr val="38BDF8"/>
-                </a:solidFill>
-              </a:defRPr>
-            </a:pPr>
-            <a:r>
-              <a:t>1. Namespaces (Visibility)</a:t>
-            </a:r>
-          </a:p>
-          <a:p>
-            <a:pPr>
-              <a:spcAft>
-                <a:spcPts val="800"/>
-              </a:spcAft>
-              <a:defRPr sz="1300">
-                <a:solidFill>
-                  <a:srgbClr val="F1F5F9"/>
-                </a:solidFill>
-              </a:defRPr>
-            </a:pPr>
-            <a:r>
-              <a:t>•  What the process can SEE.</a:t>
-            </a:r>
-          </a:p>
-          <a:p>
-            <a:pPr>
-              <a:spcAft>
-                <a:spcPts val="800"/>
-              </a:spcAft>
-              <a:defRPr sz="1300">
-                <a:solidFill>
-                  <a:srgbClr val="F1F5F9"/>
-                </a:solidFill>
-              </a:defRPr>
-            </a:pPr>
-            <a:r>
-              <a:t>•  CLONE_NEWPID: Child becomes PID 1; host processes hidden.</a:t>
-            </a:r>
-          </a:p>
-          <a:p>
-            <a:pPr>
-              <a:spcAft>
-                <a:spcPts val="800"/>
-              </a:spcAft>
-              <a:defRPr sz="1300">
-                <a:solidFill>
-                  <a:srgbClr val="F1F5F9"/>
-                </a:solidFill>
-              </a:defRPr>
-            </a:pPr>
-            <a:r>
-              <a:t>•  CLONE_NEWUTS: Independent hostname without altering host OS.</a:t>
-            </a:r>
-          </a:p>
-          <a:p>
-            <a:pPr>
-              <a:spcAft>
-                <a:spcPts val="800"/>
-              </a:spcAft>
-              <a:defRPr sz="1300">
-                <a:solidFill>
-                  <a:srgbClr val="F1F5F9"/>
-                </a:solidFill>
-              </a:defRPr>
-            </a:pPr>
-            <a:r>
-              <a:t>•  CLONE_NEWNS: Decouples VFS mount table.</a:t>
-            </a:r>
-          </a:p>
-          <a:p>
-            <a:pPr>
-              <a:spcAft>
-                <a:spcPts val="800"/>
-              </a:spcAft>
-              <a:defRPr sz="1300">
-                <a:solidFill>
-                  <a:srgbClr val="F1F5F9"/>
-                </a:solidFill>
-              </a:defRPr>
-            </a:pPr>
-            <a:r>
-              <a:t>•  CLONE_NEWIPC: Separate System V / POSIX IPC queues.</a:t>
-            </a:r>
-          </a:p>
-        </p:txBody>
-      </p:sp>
-      <p:sp>
-        <p:nvSpPr>
-          <p:cNvPr id="8" name="Rounded Rectangle 7"/>
+          <p:cNvPr id="7" name="Rounded Rectangle 6"/>
           <p:cNvSpPr/>
           <p:nvPr/>
         </p:nvSpPr>
         <p:spPr>
           <a:xfrm>
-            <a:off x="4389120" y="1645920"/>
-            <a:ext cx="3383280" cy="4480560"/>
+            <a:off x="749808" y="1618488"/>
+            <a:ext cx="3346704" cy="91440"/>
           </a:xfrm>
           <a:prstGeom prst="roundRect">
             <a:avLst/>
           </a:prstGeom>
           <a:solidFill>
-            <a:srgbClr val="151D30"/>
+            <a:srgbClr val="0284C7"/>
           </a:solidFill>
-          <a:ln w="19050">
+          <a:ln>
             <a:solidFill>
-              <a:srgbClr val="243354"/>
+              <a:srgbClr val="0284C7"/>
             </a:solidFill>
           </a:ln>
         </p:spPr>
@@ -5485,14 +5641,14 @@
       </p:sp>
       <p:sp>
         <p:nvSpPr>
-          <p:cNvPr id="9" name="TextBox 8"/>
+          <p:cNvPr id="8" name="TextBox 7"/>
           <p:cNvSpPr txBox="1"/>
           <p:nvPr/>
         </p:nvSpPr>
         <p:spPr>
           <a:xfrm>
-            <a:off x="4572000" y="1828800"/>
-            <a:ext cx="3017520" cy="4114800"/>
+            <a:off x="960120" y="1801368"/>
+            <a:ext cx="2926080" cy="4343400"/>
           </a:xfrm>
           <a:prstGeom prst="rect">
             <a:avLst/>
@@ -5507,115 +5663,115 @@
           <a:p>
             <a:pPr>
               <a:spcAft>
-                <a:spcPts val="1000"/>
-              </a:spcAft>
-              <a:defRPr sz="1600" b="1">
-                <a:solidFill>
-                  <a:srgbClr val="818CF8"/>
-                </a:solidFill>
-              </a:defRPr>
-            </a:pPr>
-            <a:r>
-              <a:t>2. Cgroups v2 (Resources)</a:t>
-            </a:r>
-          </a:p>
-          <a:p>
-            <a:pPr>
-              <a:spcAft>
                 <a:spcPts val="800"/>
               </a:spcAft>
-              <a:defRPr sz="1300">
-                <a:solidFill>
-                  <a:srgbClr val="F1F5F9"/>
-                </a:solidFill>
-              </a:defRPr>
-            </a:pPr>
-            <a:r>
-              <a:t>•  What the process can USE.</a:t>
+              <a:defRPr sz="1500" b="1">
+                <a:solidFill>
+                  <a:srgbClr val="0284C7"/>
+                </a:solidFill>
+              </a:defRPr>
+            </a:pPr>
+            <a:r>
+              <a:t>1. Namespaces (Visibility)</a:t>
             </a:r>
           </a:p>
           <a:p>
             <a:pPr>
               <a:spcAft>
-                <a:spcPts val="800"/>
+                <a:spcPts val="600"/>
               </a:spcAft>
-              <a:defRPr sz="1300">
-                <a:solidFill>
-                  <a:srgbClr val="F1F5F9"/>
-                </a:solidFill>
-              </a:defRPr>
-            </a:pPr>
-            <a:r>
-              <a:t>•  memory.max: Strict RAM ceiling; triggers kernel OOM Killer.</a:t>
+              <a:defRPr sz="1200">
+                <a:solidFill>
+                  <a:srgbClr val="0F172A"/>
+                </a:solidFill>
+              </a:defRPr>
+            </a:pPr>
+            <a:r>
+              <a:t>•  Controls what the process can SEE.</a:t>
             </a:r>
           </a:p>
           <a:p>
             <a:pPr>
               <a:spcAft>
-                <a:spcPts val="800"/>
+                <a:spcPts val="600"/>
               </a:spcAft>
-              <a:defRPr sz="1300">
-                <a:solidFill>
-                  <a:srgbClr val="F1F5F9"/>
-                </a:solidFill>
-              </a:defRPr>
-            </a:pPr>
-            <a:r>
-              <a:t>•  cpu.max: CFS scheduler bandwidth quota (e.g. 40% cap).</a:t>
+              <a:defRPr sz="1200">
+                <a:solidFill>
+                  <a:srgbClr val="0F172A"/>
+                </a:solidFill>
+              </a:defRPr>
+            </a:pPr>
+            <a:r>
+              <a:t>•  CLONE_NEWPID: Virtualizes process tree; child becomes PID 1; host tasks hidden.</a:t>
             </a:r>
           </a:p>
           <a:p>
             <a:pPr>
               <a:spcAft>
-                <a:spcPts val="800"/>
+                <a:spcPts val="600"/>
               </a:spcAft>
-              <a:defRPr sz="1300">
-                <a:solidFill>
-                  <a:srgbClr val="F1F5F9"/>
-                </a:solidFill>
-              </a:defRPr>
-            </a:pPr>
-            <a:r>
-              <a:t>•  cpu.weight: Proportional fair-share scheduling (1-10000).</a:t>
+              <a:defRPr sz="1200">
+                <a:solidFill>
+                  <a:srgbClr val="0F172A"/>
+                </a:solidFill>
+              </a:defRPr>
+            </a:pPr>
+            <a:r>
+              <a:t>•  CLONE_NEWUTS: Isolates nodename/hostname without altering host identity.</a:t>
             </a:r>
           </a:p>
           <a:p>
             <a:pPr>
               <a:spcAft>
-                <a:spcPts val="800"/>
+                <a:spcPts val="600"/>
               </a:spcAft>
-              <a:defRPr sz="1300">
-                <a:solidFill>
-                  <a:srgbClr val="F1F5F9"/>
-                </a:solidFill>
-              </a:defRPr>
-            </a:pPr>
-            <a:r>
-              <a:t>•  pids.max: Prevents fork bomb process exhaustion.</a:t>
-            </a:r>
-          </a:p>
-        </p:txBody>
-      </p:sp>
-      <p:sp>
-        <p:nvSpPr>
-          <p:cNvPr id="10" name="Rounded Rectangle 9"/>
+              <a:defRPr sz="1200">
+                <a:solidFill>
+                  <a:srgbClr val="0F172A"/>
+                </a:solidFill>
+              </a:defRPr>
+            </a:pPr>
+            <a:r>
+              <a:t>•  CLONE_NEWNS: Isolates Virtual File System (VFS) mount table.</a:t>
+            </a:r>
+          </a:p>
+          <a:p>
+            <a:pPr>
+              <a:spcAft>
+                <a:spcPts val="600"/>
+              </a:spcAft>
+              <a:defRPr sz="1200">
+                <a:solidFill>
+                  <a:srgbClr val="0F172A"/>
+                </a:solidFill>
+              </a:defRPr>
+            </a:pPr>
+            <a:r>
+              <a:t>•  CLONE_NEWIPC: Isolates POSIX and System V message queues &amp; semaphores.</a:t>
+            </a:r>
+          </a:p>
+        </p:txBody>
+      </p:sp>
+      <p:sp>
+        <p:nvSpPr>
+          <p:cNvPr id="9" name="Rounded Rectangle 8"/>
           <p:cNvSpPr/>
           <p:nvPr/>
         </p:nvSpPr>
         <p:spPr>
           <a:xfrm>
-            <a:off x="8046720" y="1645920"/>
-            <a:ext cx="3383280" cy="4480560"/>
+            <a:off x="4389120" y="1600200"/>
+            <a:ext cx="3383280" cy="4663440"/>
           </a:xfrm>
           <a:prstGeom prst="roundRect">
             <a:avLst/>
           </a:prstGeom>
           <a:solidFill>
-            <a:srgbClr val="151D30"/>
+            <a:srgbClr val="FFFFFF"/>
           </a:solidFill>
           <a:ln w="19050">
             <a:solidFill>
-              <a:srgbClr val="243354"/>
+              <a:srgbClr val="CBD5E1"/>
             </a:solidFill>
           </a:ln>
         </p:spPr>
@@ -5643,14 +5799,59 @@
       </p:sp>
       <p:sp>
         <p:nvSpPr>
+          <p:cNvPr id="10" name="Rounded Rectangle 9"/>
+          <p:cNvSpPr/>
+          <p:nvPr/>
+        </p:nvSpPr>
+        <p:spPr>
+          <a:xfrm>
+            <a:off x="4407408" y="1618488"/>
+            <a:ext cx="3346704" cy="91440"/>
+          </a:xfrm>
+          <a:prstGeom prst="roundRect">
+            <a:avLst/>
+          </a:prstGeom>
+          <a:solidFill>
+            <a:srgbClr val="4F46E5"/>
+          </a:solidFill>
+          <a:ln>
+            <a:solidFill>
+              <a:srgbClr val="4F46E5"/>
+            </a:solidFill>
+          </a:ln>
+        </p:spPr>
+        <p:style>
+          <a:lnRef idx="1">
+            <a:schemeClr val="accent1"/>
+          </a:lnRef>
+          <a:fillRef idx="3">
+            <a:schemeClr val="accent1"/>
+          </a:fillRef>
+          <a:effectRef idx="2">
+            <a:schemeClr val="accent1"/>
+          </a:effectRef>
+          <a:fontRef idx="minor">
+            <a:schemeClr val="lt1"/>
+          </a:fontRef>
+        </p:style>
+        <p:txBody>
+          <a:bodyPr rtlCol="0" anchor="ctr"/>
+          <a:lstStyle/>
+          <a:p>
+            <a:pPr algn="ctr"/>
+          </a:p>
+        </p:txBody>
+      </p:sp>
+      <p:sp>
+        <p:nvSpPr>
           <p:cNvPr id="11" name="TextBox 10"/>
           <p:cNvSpPr txBox="1"/>
           <p:nvPr/>
         </p:nvSpPr>
         <p:spPr>
           <a:xfrm>
-            <a:off x="8229600" y="1828800"/>
-            <a:ext cx="3017520" cy="4114800"/>
+            <a:off x="4617720" y="1801368"/>
+            <a:ext cx="2926080" cy="4343400"/>
           </a:xfrm>
           <a:prstGeom prst="rect">
             <a:avLst/>
@@ -5665,71 +5866,274 @@
           <a:p>
             <a:pPr>
               <a:spcAft>
-                <a:spcPts val="1000"/>
+                <a:spcPts val="800"/>
               </a:spcAft>
-              <a:defRPr sz="1600" b="1">
-                <a:solidFill>
-                  <a:srgbClr val="34D399"/>
-                </a:solidFill>
-              </a:defRPr>
-            </a:pPr>
-            <a:r>
-              <a:t>3. Rootfs Sandboxing</a:t>
-            </a:r>
-          </a:p>
+              <a:defRPr sz="1500" b="1">
+                <a:solidFill>
+                  <a:srgbClr val="4F46E5"/>
+                </a:solidFill>
+              </a:defRPr>
+            </a:pPr>
+            <a:r>
+              <a:t>2. Cgroups v2 (Resources)</a:t>
+            </a:r>
+          </a:p>
+          <a:p>
+            <a:pPr>
+              <a:spcAft>
+                <a:spcPts val="600"/>
+              </a:spcAft>
+              <a:defRPr sz="1200">
+                <a:solidFill>
+                  <a:srgbClr val="0F172A"/>
+                </a:solidFill>
+              </a:defRPr>
+            </a:pPr>
+            <a:r>
+              <a:t>•  Controls what the process can USE.</a:t>
+            </a:r>
+          </a:p>
+          <a:p>
+            <a:pPr>
+              <a:spcAft>
+                <a:spcPts val="600"/>
+              </a:spcAft>
+              <a:defRPr sz="1200">
+                <a:solidFill>
+                  <a:srgbClr val="0F172A"/>
+                </a:solidFill>
+              </a:defRPr>
+            </a:pPr>
+            <a:r>
+              <a:t>•  memory.max: Strict RAM ceiling; triggers kernel OOM Killer.</a:t>
+            </a:r>
+          </a:p>
+          <a:p>
+            <a:pPr>
+              <a:spcAft>
+                <a:spcPts val="600"/>
+              </a:spcAft>
+              <a:defRPr sz="1200">
+                <a:solidFill>
+                  <a:srgbClr val="0F172A"/>
+                </a:solidFill>
+              </a:defRPr>
+            </a:pPr>
+            <a:r>
+              <a:t>•  cpu.max: CFS scheduler bandwidth quota (e.g. 40% compute cap).</a:t>
+            </a:r>
+          </a:p>
+          <a:p>
+            <a:pPr>
+              <a:spcAft>
+                <a:spcPts val="600"/>
+              </a:spcAft>
+              <a:defRPr sz="1200">
+                <a:solidFill>
+                  <a:srgbClr val="0F172A"/>
+                </a:solidFill>
+              </a:defRPr>
+            </a:pPr>
+            <a:r>
+              <a:t>•  cpu.weight: Proportional fair-share scheduling (1 - 10000).</a:t>
+            </a:r>
+          </a:p>
+          <a:p>
+            <a:pPr>
+              <a:spcAft>
+                <a:spcPts val="600"/>
+              </a:spcAft>
+              <a:defRPr sz="1200">
+                <a:solidFill>
+                  <a:srgbClr val="0F172A"/>
+                </a:solidFill>
+              </a:defRPr>
+            </a:pPr>
+            <a:r>
+              <a:t>•  pids.max: Prevents process table saturation &amp; fork bombs.</a:t>
+            </a:r>
+          </a:p>
+        </p:txBody>
+      </p:sp>
+      <p:sp>
+        <p:nvSpPr>
+          <p:cNvPr id="12" name="Rounded Rectangle 11"/>
+          <p:cNvSpPr/>
+          <p:nvPr/>
+        </p:nvSpPr>
+        <p:spPr>
+          <a:xfrm>
+            <a:off x="8046720" y="1600200"/>
+            <a:ext cx="3383280" cy="4663440"/>
+          </a:xfrm>
+          <a:prstGeom prst="roundRect">
+            <a:avLst/>
+          </a:prstGeom>
+          <a:solidFill>
+            <a:srgbClr val="FFFFFF"/>
+          </a:solidFill>
+          <a:ln w="19050">
+            <a:solidFill>
+              <a:srgbClr val="CBD5E1"/>
+            </a:solidFill>
+          </a:ln>
+        </p:spPr>
+        <p:style>
+          <a:lnRef idx="1">
+            <a:schemeClr val="accent1"/>
+          </a:lnRef>
+          <a:fillRef idx="3">
+            <a:schemeClr val="accent1"/>
+          </a:fillRef>
+          <a:effectRef idx="2">
+            <a:schemeClr val="accent1"/>
+          </a:effectRef>
+          <a:fontRef idx="minor">
+            <a:schemeClr val="lt1"/>
+          </a:fontRef>
+        </p:style>
+        <p:txBody>
+          <a:bodyPr rtlCol="0" anchor="ctr"/>
+          <a:lstStyle/>
+          <a:p>
+            <a:pPr algn="ctr"/>
+          </a:p>
+        </p:txBody>
+      </p:sp>
+      <p:sp>
+        <p:nvSpPr>
+          <p:cNvPr id="13" name="Rounded Rectangle 12"/>
+          <p:cNvSpPr/>
+          <p:nvPr/>
+        </p:nvSpPr>
+        <p:spPr>
+          <a:xfrm>
+            <a:off x="8065008" y="1618488"/>
+            <a:ext cx="3346704" cy="91440"/>
+          </a:xfrm>
+          <a:prstGeom prst="roundRect">
+            <a:avLst/>
+          </a:prstGeom>
+          <a:solidFill>
+            <a:srgbClr val="10B981"/>
+          </a:solidFill>
+          <a:ln>
+            <a:solidFill>
+              <a:srgbClr val="10B981"/>
+            </a:solidFill>
+          </a:ln>
+        </p:spPr>
+        <p:style>
+          <a:lnRef idx="1">
+            <a:schemeClr val="accent1"/>
+          </a:lnRef>
+          <a:fillRef idx="3">
+            <a:schemeClr val="accent1"/>
+          </a:fillRef>
+          <a:effectRef idx="2">
+            <a:schemeClr val="accent1"/>
+          </a:effectRef>
+          <a:fontRef idx="minor">
+            <a:schemeClr val="lt1"/>
+          </a:fontRef>
+        </p:style>
+        <p:txBody>
+          <a:bodyPr rtlCol="0" anchor="ctr"/>
+          <a:lstStyle/>
+          <a:p>
+            <a:pPr algn="ctr"/>
+          </a:p>
+        </p:txBody>
+      </p:sp>
+      <p:sp>
+        <p:nvSpPr>
+          <p:cNvPr id="14" name="TextBox 13"/>
+          <p:cNvSpPr txBox="1"/>
+          <p:nvPr/>
+        </p:nvSpPr>
+        <p:spPr>
+          <a:xfrm>
+            <a:off x="8275320" y="1801368"/>
+            <a:ext cx="2926080" cy="4343400"/>
+          </a:xfrm>
+          <a:prstGeom prst="rect">
+            <a:avLst/>
+          </a:prstGeom>
+          <a:noFill/>
+        </p:spPr>
+        <p:txBody>
+          <a:bodyPr wrap="square">
+            <a:spAutoFit/>
+          </a:bodyPr>
+          <a:lstStyle/>
           <a:p>
             <a:pPr>
               <a:spcAft>
                 <a:spcPts val="800"/>
               </a:spcAft>
-              <a:defRPr sz="1300">
-                <a:solidFill>
-                  <a:srgbClr val="F1F5F9"/>
-                </a:solidFill>
-              </a:defRPr>
-            </a:pPr>
-            <a:r>
-              <a:t>•  Where the process can TOUCH.</a:t>
+              <a:defRPr sz="1500" b="1">
+                <a:solidFill>
+                  <a:srgbClr val="10B981"/>
+                </a:solidFill>
+              </a:defRPr>
+            </a:pPr>
+            <a:r>
+              <a:t>3. Rootfs Sandboxing</a:t>
             </a:r>
           </a:p>
           <a:p>
             <a:pPr>
               <a:spcAft>
-                <a:spcPts val="800"/>
+                <a:spcPts val="600"/>
               </a:spcAft>
-              <a:defRPr sz="1300">
-                <a:solidFill>
-                  <a:srgbClr val="F1F5F9"/>
-                </a:solidFill>
-              </a:defRPr>
-            </a:pPr>
-            <a:r>
-              <a:t>•  Alpine Linux Rootfs: Lightweight ~3.5MB userland.</a:t>
+              <a:defRPr sz="1200">
+                <a:solidFill>
+                  <a:srgbClr val="0F172A"/>
+                </a:solidFill>
+              </a:defRPr>
+            </a:pPr>
+            <a:r>
+              <a:t>•  Controls where the process can TOUCH.</a:t>
             </a:r>
           </a:p>
           <a:p>
             <a:pPr>
               <a:spcAft>
-                <a:spcPts val="800"/>
+                <a:spcPts val="600"/>
               </a:spcAft>
-              <a:defRPr sz="1300">
-                <a:solidFill>
-                  <a:srgbClr val="F1F5F9"/>
-                </a:solidFill>
-              </a:defRPr>
-            </a:pPr>
-            <a:r>
-              <a:t>•  chroot(): Cages process inside container directory tree.</a:t>
+              <a:defRPr sz="1200">
+                <a:solidFill>
+                  <a:srgbClr val="0F172A"/>
+                </a:solidFill>
+              </a:defRPr>
+            </a:pPr>
+            <a:r>
+              <a:t>•  Alpine Linux Rootfs: Lightweight ~3.5MB container userland.</a:t>
             </a:r>
           </a:p>
           <a:p>
             <a:pPr>
               <a:spcAft>
-                <a:spcPts val="800"/>
+                <a:spcPts val="600"/>
               </a:spcAft>
-              <a:defRPr sz="1300">
-                <a:solidFill>
-                  <a:srgbClr val="F1F5F9"/>
+              <a:defRPr sz="1200">
+                <a:solidFill>
+                  <a:srgbClr val="0F172A"/>
+                </a:solidFill>
+              </a:defRPr>
+            </a:pPr>
+            <a:r>
+              <a:t>•  chroot(): Confines process inside container directory tree.</a:t>
+            </a:r>
+          </a:p>
+          <a:p>
+            <a:pPr>
+              <a:spcAft>
+                <a:spcPts val="600"/>
+              </a:spcAft>
+              <a:defRPr sz="1200">
+                <a:solidFill>
+                  <a:srgbClr val="0F172A"/>
                 </a:solidFill>
               </a:defRPr>
             </a:pPr>
@@ -5740,16 +6144,16 @@
           <a:p>
             <a:pPr>
               <a:spcAft>
-                <a:spcPts val="800"/>
+                <a:spcPts val="600"/>
               </a:spcAft>
-              <a:defRPr sz="1300">
-                <a:solidFill>
-                  <a:srgbClr val="F1F5F9"/>
-                </a:solidFill>
-              </a:defRPr>
-            </a:pPr>
-            <a:r>
-              <a:t>•  Prevents host directory traversal.</a:t>
+              <a:defRPr sz="1200">
+                <a:solidFill>
+                  <a:srgbClr val="0F172A"/>
+                </a:solidFill>
+              </a:defRPr>
+            </a:pPr>
+            <a:r>
+              <a:t>•  Prevents traversal into host root filesystems.</a:t>
             </a:r>
           </a:p>
         </p:txBody>
@@ -5787,11 +6191,11 @@
             <a:avLst/>
           </a:prstGeom>
           <a:solidFill>
-            <a:srgbClr val="0B0F19"/>
+            <a:srgbClr val="F8FAFC"/>
           </a:solidFill>
           <a:ln>
             <a:solidFill>
-              <a:srgbClr val="0B0F19"/>
+              <a:srgbClr val="F8FAFC"/>
             </a:solidFill>
           </a:ln>
         </p:spPr>
@@ -5826,7 +6230,7 @@
         <p:spPr>
           <a:xfrm>
             <a:off x="731520" y="365760"/>
-            <a:ext cx="10515600" cy="365760"/>
+            <a:ext cx="10698480" cy="320040"/>
           </a:xfrm>
           <a:prstGeom prst="rect">
             <a:avLst/>
@@ -5842,12 +6246,12 @@
             <a:pPr>
               <a:defRPr sz="1100" b="1">
                 <a:solidFill>
-                  <a:srgbClr val="818CF8"/>
-                </a:solidFill>
-              </a:defRPr>
-            </a:pPr>
-            <a:r>
-              <a:t>LABORATORY BENCHMARKS</a:t>
+                  <a:srgbClr val="0284C7"/>
+                </a:solidFill>
+              </a:defRPr>
+            </a:pPr>
+            <a:r>
+              <a:t>CONCURRENCY PRIMITIVES</a:t>
             </a:r>
           </a:p>
         </p:txBody>
@@ -5860,8 +6264,8 @@
         </p:nvSpPr>
         <p:spPr>
           <a:xfrm>
-            <a:off x="731520" y="640080"/>
-            <a:ext cx="10515600" cy="640080"/>
+            <a:off x="731520" y="621792"/>
+            <a:ext cx="10698480" cy="640080"/>
           </a:xfrm>
           <a:prstGeom prst="rect">
             <a:avLst/>
@@ -5877,12 +6281,12 @@
             <a:pPr>
               <a:defRPr sz="2400" b="1">
                 <a:solidFill>
-                  <a:srgbClr val="F1F5F9"/>
-                </a:solidFill>
-              </a:defRPr>
-            </a:pPr>
-            <a:r>
-              <a:t>Empirical Results &amp; Live Verification</a:t>
+                  <a:srgbClr val="0F172A"/>
+                </a:solidFill>
+              </a:defRPr>
+            </a:pPr>
+            <a:r>
+              <a:t>Classical Concurrency &amp; IPC Synchronization (CO: 3)</a:t>
             </a:r>
           </a:p>
         </p:txBody>
@@ -5895,18 +6299,18 @@
         </p:nvSpPr>
         <p:spPr>
           <a:xfrm>
-            <a:off x="731520" y="1325880"/>
-            <a:ext cx="10698480" cy="18288"/>
+            <a:off x="731520" y="1298448"/>
+            <a:ext cx="10698480" cy="27432"/>
           </a:xfrm>
           <a:prstGeom prst="rect">
             <a:avLst/>
           </a:prstGeom>
           <a:solidFill>
-            <a:srgbClr val="243354"/>
+            <a:srgbClr val="0284C7"/>
           </a:solidFill>
           <a:ln>
             <a:solidFill>
-              <a:srgbClr val="243354"/>
+              <a:srgbClr val="0284C7"/>
             </a:solidFill>
           </a:ln>
         </p:spPr>
@@ -5940,18 +6344,18 @@
         </p:nvSpPr>
         <p:spPr>
           <a:xfrm>
-            <a:off x="731520" y="1645920"/>
-            <a:ext cx="5120640" cy="2148840"/>
+            <a:off x="731520" y="1600200"/>
+            <a:ext cx="5120640" cy="4663440"/>
           </a:xfrm>
           <a:prstGeom prst="roundRect">
             <a:avLst/>
           </a:prstGeom>
           <a:solidFill>
-            <a:srgbClr val="151D30"/>
+            <a:srgbClr val="FFFFFF"/>
           </a:solidFill>
           <a:ln w="19050">
             <a:solidFill>
-              <a:srgbClr val="243354"/>
+              <a:srgbClr val="CBD5E1"/>
             </a:solidFill>
           </a:ln>
         </p:spPr>
@@ -5979,107 +6383,24 @@
       </p:sp>
       <p:sp>
         <p:nvSpPr>
-          <p:cNvPr id="7" name="TextBox 6"/>
-          <p:cNvSpPr txBox="1"/>
-          <p:nvPr/>
-        </p:nvSpPr>
-        <p:spPr>
-          <a:xfrm>
-            <a:off x="914400" y="1828800"/>
-            <a:ext cx="4754880" cy="1783080"/>
-          </a:xfrm>
-          <a:prstGeom prst="rect">
-            <a:avLst/>
-          </a:prstGeom>
-          <a:noFill/>
-        </p:spPr>
-        <p:txBody>
-          <a:bodyPr wrap="square">
-            <a:spAutoFit/>
-          </a:bodyPr>
-          <a:lstStyle/>
-          <a:p>
-            <a:pPr>
-              <a:spcAft>
-                <a:spcPts val="1000"/>
-              </a:spcAft>
-              <a:defRPr sz="1600" b="1">
-                <a:solidFill>
-                  <a:srgbClr val="38BDF8"/>
-                </a:solidFill>
-              </a:defRPr>
-            </a:pPr>
-            <a:r>
-              <a:t>1. PID &amp; Hostname Isolation (CO: 1 &amp; 5)</a:t>
-            </a:r>
-          </a:p>
-          <a:p>
-            <a:pPr>
-              <a:spcAft>
-                <a:spcPts val="800"/>
-              </a:spcAft>
-              <a:defRPr sz="1300">
-                <a:solidFill>
-                  <a:srgbClr val="F1F5F9"/>
-                </a:solidFill>
-              </a:defRPr>
-            </a:pPr>
-            <a:r>
-              <a:t>•  Command: sudo ./minicontainer run ./tests/test_info</a:t>
-            </a:r>
-          </a:p>
-          <a:p>
-            <a:pPr>
-              <a:spcAft>
-                <a:spcPts val="800"/>
-              </a:spcAft>
-              <a:defRPr sz="1300">
-                <a:solidFill>
-                  <a:srgbClr val="F1F5F9"/>
-                </a:solidFill>
-              </a:defRPr>
-            </a:pPr>
-            <a:r>
-              <a:t>•  Result: Child reports PID = 1; Parent PID = 0.</a:t>
-            </a:r>
-          </a:p>
-          <a:p>
-            <a:pPr>
-              <a:spcAft>
-                <a:spcPts val="800"/>
-              </a:spcAft>
-              <a:defRPr sz="1300">
-                <a:solidFill>
-                  <a:srgbClr val="F1F5F9"/>
-                </a:solidFill>
-              </a:defRPr>
-            </a:pPr>
-            <a:r>
-              <a:t>•  Host processes (47 running) are completely hidden.</a:t>
-            </a:r>
-          </a:p>
-        </p:txBody>
-      </p:sp>
-      <p:sp>
-        <p:nvSpPr>
-          <p:cNvPr id="8" name="Rounded Rectangle 7"/>
+          <p:cNvPr id="7" name="Rounded Rectangle 6"/>
           <p:cNvSpPr/>
           <p:nvPr/>
         </p:nvSpPr>
         <p:spPr>
           <a:xfrm>
-            <a:off x="6217920" y="1645920"/>
-            <a:ext cx="5120640" cy="2148840"/>
+            <a:off x="749808" y="1618488"/>
+            <a:ext cx="5084064" cy="91440"/>
           </a:xfrm>
           <a:prstGeom prst="roundRect">
             <a:avLst/>
           </a:prstGeom>
           <a:solidFill>
-            <a:srgbClr val="151D30"/>
+            <a:srgbClr val="10B981"/>
           </a:solidFill>
-          <a:ln w="19050">
+          <a:ln>
             <a:solidFill>
-              <a:srgbClr val="243354"/>
+              <a:srgbClr val="10B981"/>
             </a:solidFill>
           </a:ln>
         </p:spPr>
@@ -6107,14 +6428,14 @@
       </p:sp>
       <p:sp>
         <p:nvSpPr>
-          <p:cNvPr id="9" name="TextBox 8"/>
+          <p:cNvPr id="8" name="TextBox 7"/>
           <p:cNvSpPr txBox="1"/>
           <p:nvPr/>
         </p:nvSpPr>
         <p:spPr>
           <a:xfrm>
-            <a:off x="6400800" y="1828800"/>
-            <a:ext cx="4754880" cy="1783080"/>
+            <a:off x="960120" y="1801368"/>
+            <a:ext cx="4663440" cy="4343400"/>
           </a:xfrm>
           <a:prstGeom prst="rect">
             <a:avLst/>
@@ -6129,85 +6450,130 @@
           <a:p>
             <a:pPr>
               <a:spcAft>
-                <a:spcPts val="1000"/>
-              </a:spcAft>
-              <a:defRPr sz="1600" b="1">
-                <a:solidFill>
-                  <a:srgbClr val="F59E0B"/>
-                </a:solidFill>
-              </a:defRPr>
-            </a:pPr>
-            <a:r>
-              <a:t>2. Memory Limit &amp; OOM Killer (CO: 4)</a:t>
-            </a:r>
-          </a:p>
-          <a:p>
-            <a:pPr>
-              <a:spcAft>
                 <a:spcPts val="800"/>
               </a:spcAft>
-              <a:defRPr sz="1300">
-                <a:solidFill>
-                  <a:srgbClr val="F1F5F9"/>
-                </a:solidFill>
-              </a:defRPr>
-            </a:pPr>
-            <a:r>
-              <a:t>•  Command: sudo ./minicontainer run --memory 30M ./tests/test_memory 60</a:t>
+              <a:defRPr sz="1500" b="1">
+                <a:solidFill>
+                  <a:srgbClr val="10B981"/>
+                </a:solidFill>
+              </a:defRPr>
+            </a:pPr>
+            <a:r>
+              <a:t>Producer-Consumer with Semaphores (sem_t)</a:t>
             </a:r>
           </a:p>
           <a:p>
             <a:pPr>
               <a:spcAft>
-                <a:spcPts val="800"/>
+                <a:spcPts val="600"/>
               </a:spcAft>
-              <a:defRPr sz="1300">
-                <a:solidFill>
-                  <a:srgbClr val="F1F5F9"/>
-                </a:solidFill>
-              </a:defRPr>
-            </a:pPr>
-            <a:r>
-              <a:t>•  Result: Process terminated by SIGKILL (signal 9).</a:t>
+              <a:defRPr sz="1200">
+                <a:solidFill>
+                  <a:srgbClr val="0F172A"/>
+                </a:solidFill>
+              </a:defRPr>
+            </a:pPr>
+            <a:r>
+              <a:t>•  Classical Bounded-Buffer Concurrency Problem implemented inside the container sandbox.</a:t>
             </a:r>
           </a:p>
           <a:p>
             <a:pPr>
               <a:spcAft>
-                <a:spcPts val="800"/>
+                <a:spcPts val="600"/>
               </a:spcAft>
-              <a:defRPr sz="1300">
-                <a:solidFill>
-                  <a:srgbClr val="F1F5F9"/>
-                </a:solidFill>
-              </a:defRPr>
-            </a:pPr>
-            <a:r>
-              <a:t>•  Recorded 7,705 Minor Page Faults proving Demand Paging!</a:t>
-            </a:r>
-          </a:p>
-        </p:txBody>
-      </p:sp>
-      <p:sp>
-        <p:nvSpPr>
-          <p:cNvPr id="10" name="Rounded Rectangle 9"/>
+              <a:defRPr sz="1200">
+                <a:solidFill>
+                  <a:srgbClr val="0F172A"/>
+                </a:solidFill>
+              </a:defRPr>
+            </a:pPr>
+            <a:r>
+              <a:t>•  Binary Semaphore (mutex): Initialized to 1; enforces mutual exclusion for the critical section.</a:t>
+            </a:r>
+          </a:p>
+          <a:p>
+            <a:pPr>
+              <a:spcAft>
+                <a:spcPts val="600"/>
+              </a:spcAft>
+              <a:defRPr sz="1200">
+                <a:solidFill>
+                  <a:srgbClr val="0F172A"/>
+                </a:solidFill>
+              </a:defRPr>
+            </a:pPr>
+            <a:r>
+              <a:t>•  Counting Semaphore (empty_slots): Initialized to buffer capacity (N = 5).</a:t>
+            </a:r>
+          </a:p>
+          <a:p>
+            <a:pPr>
+              <a:spcAft>
+                <a:spcPts val="600"/>
+              </a:spcAft>
+              <a:defRPr sz="1200">
+                <a:solidFill>
+                  <a:srgbClr val="0F172A"/>
+                </a:solidFill>
+              </a:defRPr>
+            </a:pPr>
+            <a:r>
+              <a:t>•  Counting Semaphore (full_slots): Initialized to 0 items available.</a:t>
+            </a:r>
+          </a:p>
+          <a:p>
+            <a:pPr>
+              <a:spcAft>
+                <a:spcPts val="600"/>
+              </a:spcAft>
+              <a:defRPr sz="1200">
+                <a:solidFill>
+                  <a:srgbClr val="0F172A"/>
+                </a:solidFill>
+              </a:defRPr>
+            </a:pPr>
+            <a:r>
+              <a:t>•  Shared Memory (mmap): Allocated via MAP_SHARED | MAP_ANONYMOUS across processes.</a:t>
+            </a:r>
+          </a:p>
+          <a:p>
+            <a:pPr>
+              <a:spcAft>
+                <a:spcPts val="600"/>
+              </a:spcAft>
+              <a:defRPr sz="1200">
+                <a:solidFill>
+                  <a:srgbClr val="0F172A"/>
+                </a:solidFill>
+              </a:defRPr>
+            </a:pPr>
+            <a:r>
+              <a:t>•  Result: All 10 operations exchanged with zero race conditions or buffer corruption.</a:t>
+            </a:r>
+          </a:p>
+        </p:txBody>
+      </p:sp>
+      <p:sp>
+        <p:nvSpPr>
+          <p:cNvPr id="9" name="Rounded Rectangle 8"/>
           <p:cNvSpPr/>
           <p:nvPr/>
         </p:nvSpPr>
         <p:spPr>
           <a:xfrm>
-            <a:off x="731520" y="3977639"/>
-            <a:ext cx="5120640" cy="2148840"/>
+            <a:off x="6217920" y="1600200"/>
+            <a:ext cx="5120640" cy="4663440"/>
           </a:xfrm>
           <a:prstGeom prst="roundRect">
             <a:avLst/>
           </a:prstGeom>
           <a:solidFill>
-            <a:srgbClr val="151D30"/>
+            <a:srgbClr val="FFFFFF"/>
           </a:solidFill>
           <a:ln w="19050">
             <a:solidFill>
-              <a:srgbClr val="243354"/>
+              <a:srgbClr val="CBD5E1"/>
             </a:solidFill>
           </a:ln>
         </p:spPr>
@@ -6235,107 +6601,24 @@
       </p:sp>
       <p:sp>
         <p:nvSpPr>
-          <p:cNvPr id="11" name="TextBox 10"/>
-          <p:cNvSpPr txBox="1"/>
-          <p:nvPr/>
-        </p:nvSpPr>
-        <p:spPr>
-          <a:xfrm>
-            <a:off x="914400" y="4160519"/>
-            <a:ext cx="4754880" cy="1783080"/>
-          </a:xfrm>
-          <a:prstGeom prst="rect">
-            <a:avLst/>
-          </a:prstGeom>
-          <a:noFill/>
-        </p:spPr>
-        <p:txBody>
-          <a:bodyPr wrap="square">
-            <a:spAutoFit/>
-          </a:bodyPr>
-          <a:lstStyle/>
-          <a:p>
-            <a:pPr>
-              <a:spcAft>
-                <a:spcPts val="1000"/>
-              </a:spcAft>
-              <a:defRPr sz="1600" b="1">
-                <a:solidFill>
-                  <a:srgbClr val="818CF8"/>
-                </a:solidFill>
-              </a:defRPr>
-            </a:pPr>
-            <a:r>
-              <a:t>3. CPU Fair-Share Contest (CO: 2)</a:t>
-            </a:r>
-          </a:p>
-          <a:p>
-            <a:pPr>
-              <a:spcAft>
-                <a:spcPts val="800"/>
-              </a:spcAft>
-              <a:defRPr sz="1300">
-                <a:solidFill>
-                  <a:srgbClr val="F1F5F9"/>
-                </a:solidFill>
-              </a:defRPr>
-            </a:pPr>
-            <a:r>
-              <a:t>•  Command: sudo bash scripts/test_cpu_shares.sh</a:t>
-            </a:r>
-          </a:p>
-          <a:p>
-            <a:pPr>
-              <a:spcAft>
-                <a:spcPts val="800"/>
-              </a:spcAft>
-              <a:defRPr sz="1300">
-                <a:solidFill>
-                  <a:srgbClr val="F1F5F9"/>
-                </a:solidFill>
-              </a:defRPr>
-            </a:pPr>
-            <a:r>
-              <a:t>•  Result: Contest on Core 0 with Weights 800 vs 200.</a:t>
-            </a:r>
-          </a:p>
-          <a:p>
-            <a:pPr>
-              <a:spcAft>
-                <a:spcPts val="800"/>
-              </a:spcAft>
-              <a:defRPr sz="1300">
-                <a:solidFill>
-                  <a:srgbClr val="F1F5F9"/>
-                </a:solidFill>
-              </a:defRPr>
-            </a:pPr>
-            <a:r>
-              <a:t>•  CPU Time: 2.78s vs 0.69s -&gt; Exact 4.02 : 1 execution ratio!</a:t>
-            </a:r>
-          </a:p>
-        </p:txBody>
-      </p:sp>
-      <p:sp>
-        <p:nvSpPr>
-          <p:cNvPr id="12" name="Rounded Rectangle 11"/>
+          <p:cNvPr id="10" name="Rounded Rectangle 9"/>
           <p:cNvSpPr/>
           <p:nvPr/>
         </p:nvSpPr>
         <p:spPr>
           <a:xfrm>
-            <a:off x="6217920" y="3977639"/>
-            <a:ext cx="5120640" cy="2148840"/>
+            <a:off x="6236208" y="1618488"/>
+            <a:ext cx="5084064" cy="91440"/>
           </a:xfrm>
           <a:prstGeom prst="roundRect">
             <a:avLst/>
           </a:prstGeom>
           <a:solidFill>
-            <a:srgbClr val="151D30"/>
+            <a:srgbClr val="0284C7"/>
           </a:solidFill>
-          <a:ln w="19050">
+          <a:ln>
             <a:solidFill>
-              <a:srgbClr val="243354"/>
+              <a:srgbClr val="0284C7"/>
             </a:solidFill>
           </a:ln>
         </p:spPr>
@@ -6363,14 +6646,14 @@
       </p:sp>
       <p:sp>
         <p:nvSpPr>
-          <p:cNvPr id="13" name="TextBox 12"/>
+          <p:cNvPr id="11" name="TextBox 10"/>
           <p:cNvSpPr txBox="1"/>
           <p:nvPr/>
         </p:nvSpPr>
         <p:spPr>
           <a:xfrm>
-            <a:off x="6400800" y="4160519"/>
-            <a:ext cx="4754880" cy="1783080"/>
+            <a:off x="6446520" y="1801368"/>
+            <a:ext cx="4663440" cy="4343400"/>
           </a:xfrm>
           <a:prstGeom prst="rect">
             <a:avLst/>
@@ -6385,61 +6668,106 @@
           <a:p>
             <a:pPr>
               <a:spcAft>
-                <a:spcPts val="1000"/>
-              </a:spcAft>
-              <a:defRPr sz="1600" b="1">
-                <a:solidFill>
-                  <a:srgbClr val="34D399"/>
-                </a:solidFill>
-              </a:defRPr>
-            </a:pPr>
-            <a:r>
-              <a:t>4. Concurrency &amp; Semaphores (CO: 3)</a:t>
-            </a:r>
-          </a:p>
-          <a:p>
-            <a:pPr>
-              <a:spcAft>
                 <a:spcPts val="800"/>
               </a:spcAft>
-              <a:defRPr sz="1300">
-                <a:solidFill>
-                  <a:srgbClr val="F1F5F9"/>
-                </a:solidFill>
-              </a:defRPr>
-            </a:pPr>
-            <a:r>
-              <a:t>•  Command: sudo ./minicontainer run ./tests/test_ipc_sync</a:t>
+              <a:defRPr sz="1500" b="1">
+                <a:solidFill>
+                  <a:srgbClr val="0284C7"/>
+                </a:solidFill>
+              </a:defRPr>
+            </a:pPr>
+            <a:r>
+              <a:t>Parent-Child IPC Pipe Synchronization</a:t>
             </a:r>
           </a:p>
           <a:p>
             <a:pPr>
               <a:spcAft>
-                <a:spcPts val="800"/>
+                <a:spcPts val="600"/>
               </a:spcAft>
-              <a:defRPr sz="1300">
-                <a:solidFill>
-                  <a:srgbClr val="F1F5F9"/>
-                </a:solidFill>
-              </a:defRPr>
-            </a:pPr>
-            <a:r>
-              <a:t>•  Result: 10 items exchanged via sem_t (mutex, empty, full).</a:t>
+              <a:defRPr sz="1200">
+                <a:solidFill>
+                  <a:srgbClr val="0F172A"/>
+                </a:solidFill>
+              </a:defRPr>
+            </a:pPr>
+            <a:r>
+              <a:t>•  The Race Condition Hazard: Cloned child process could execute payload before parent attaches cgroups limits.</a:t>
             </a:r>
           </a:p>
           <a:p>
             <a:pPr>
               <a:spcAft>
-                <a:spcPts val="800"/>
+                <a:spcPts val="600"/>
               </a:spcAft>
-              <a:defRPr sz="1300">
-                <a:solidFill>
-                  <a:srgbClr val="F1F5F9"/>
-                </a:solidFill>
-              </a:defRPr>
-            </a:pPr>
-            <a:r>
-              <a:t>•  Shared memory ring buffer executed with zero race conditions.</a:t>
+              <a:defRPr sz="1200">
+                <a:solidFill>
+                  <a:srgbClr val="0F172A"/>
+                </a:solidFill>
+              </a:defRPr>
+            </a:pPr>
+            <a:r>
+              <a:t>•  The POSIX Pipe Solution: Parent and child share a unidirectional sync_pipe[2].</a:t>
+            </a:r>
+          </a:p>
+          <a:p>
+            <a:pPr>
+              <a:spcAft>
+                <a:spcPts val="600"/>
+              </a:spcAft>
+              <a:defRPr sz="1200">
+                <a:solidFill>
+                  <a:srgbClr val="0F172A"/>
+                </a:solidFill>
+              </a:defRPr>
+            </a:pPr>
+            <a:r>
+              <a:t>•  Child Execution: Calls read(sync_pipe[0]) and immediately BLOCKS.</a:t>
+            </a:r>
+          </a:p>
+          <a:p>
+            <a:pPr>
+              <a:spcAft>
+                <a:spcPts val="600"/>
+              </a:spcAft>
+              <a:defRPr sz="1200">
+                <a:solidFill>
+                  <a:srgbClr val="0F172A"/>
+                </a:solidFill>
+              </a:defRPr>
+            </a:pPr>
+            <a:r>
+              <a:t>•  Parent Execution: Completes cgroup setup, then writes single trigger byte 'G'.</a:t>
+            </a:r>
+          </a:p>
+          <a:p>
+            <a:pPr>
+              <a:spcAft>
+                <a:spcPts val="600"/>
+              </a:spcAft>
+              <a:defRPr sz="1200">
+                <a:solidFill>
+                  <a:srgbClr val="0F172A"/>
+                </a:solidFill>
+              </a:defRPr>
+            </a:pPr>
+            <a:r>
+              <a:t>•  Unblocking: Child receives byte, closes pipe, and proceeds safely to execvp().</a:t>
+            </a:r>
+          </a:p>
+          <a:p>
+            <a:pPr>
+              <a:spcAft>
+                <a:spcPts val="600"/>
+              </a:spcAft>
+              <a:defRPr sz="1200">
+                <a:solidFill>
+                  <a:srgbClr val="0F172A"/>
+                </a:solidFill>
+              </a:defRPr>
+            </a:pPr>
+            <a:r>
+              <a:t>•  Ensures deterministic, race-free resource limits from microsecond zero.</a:t>
             </a:r>
           </a:p>
         </p:txBody>
@@ -6477,11 +6805,11 @@
             <a:avLst/>
           </a:prstGeom>
           <a:solidFill>
-            <a:srgbClr val="0B0F19"/>
+            <a:srgbClr val="F8FAFC"/>
           </a:solidFill>
           <a:ln>
             <a:solidFill>
-              <a:srgbClr val="0B0F19"/>
+              <a:srgbClr val="F8FAFC"/>
             </a:solidFill>
           </a:ln>
         </p:spPr>
@@ -6516,7 +6844,7 @@
         <p:spPr>
           <a:xfrm>
             <a:off x="731520" y="365760"/>
-            <a:ext cx="10515600" cy="365760"/>
+            <a:ext cx="10698480" cy="320040"/>
           </a:xfrm>
           <a:prstGeom prst="rect">
             <a:avLst/>
@@ -6532,12 +6860,12 @@
             <a:pPr>
               <a:defRPr sz="1100" b="1">
                 <a:solidFill>
-                  <a:srgbClr val="818CF8"/>
-                </a:solidFill>
-              </a:defRPr>
-            </a:pPr>
-            <a:r>
-              <a:t>EVALUATOR Q&amp;A</a:t>
+                  <a:srgbClr val="0284C7"/>
+                </a:solidFill>
+              </a:defRPr>
+            </a:pPr>
+            <a:r>
+              <a:t>OBSERVED METRICS</a:t>
             </a:r>
           </a:p>
         </p:txBody>
@@ -6550,8 +6878,8 @@
         </p:nvSpPr>
         <p:spPr>
           <a:xfrm>
-            <a:off x="731520" y="640080"/>
-            <a:ext cx="10515600" cy="640080"/>
+            <a:off x="731520" y="621792"/>
+            <a:ext cx="10698480" cy="640080"/>
           </a:xfrm>
           <a:prstGeom prst="rect">
             <a:avLst/>
@@ -6567,12 +6895,12 @@
             <a:pPr>
               <a:defRPr sz="2400" b="1">
                 <a:solidFill>
-                  <a:srgbClr val="F1F5F9"/>
-                </a:solidFill>
-              </a:defRPr>
-            </a:pPr>
-            <a:r>
-              <a:t>Technical Review &amp; Viva Voce Defense</a:t>
+                  <a:srgbClr val="0F172A"/>
+                </a:solidFill>
+              </a:defRPr>
+            </a:pPr>
+            <a:r>
+              <a:t>Empirical Laboratory Benchmarks &amp; Verification</a:t>
             </a:r>
           </a:p>
         </p:txBody>
@@ -6585,18 +6913,18 @@
         </p:nvSpPr>
         <p:spPr>
           <a:xfrm>
-            <a:off x="731520" y="1325880"/>
-            <a:ext cx="10698480" cy="18288"/>
+            <a:off x="731520" y="1298448"/>
+            <a:ext cx="10698480" cy="27432"/>
           </a:xfrm>
           <a:prstGeom prst="rect">
             <a:avLst/>
           </a:prstGeom>
           <a:solidFill>
-            <a:srgbClr val="243354"/>
+            <a:srgbClr val="0284C7"/>
           </a:solidFill>
           <a:ln>
             <a:solidFill>
-              <a:srgbClr val="243354"/>
+              <a:srgbClr val="0284C7"/>
             </a:solidFill>
           </a:ln>
         </p:spPr>
@@ -6630,18 +6958,18 @@
         </p:nvSpPr>
         <p:spPr>
           <a:xfrm>
-            <a:off x="731520" y="1645920"/>
-            <a:ext cx="5120640" cy="2148840"/>
+            <a:off x="731520" y="1600200"/>
+            <a:ext cx="5120640" cy="2194560"/>
           </a:xfrm>
           <a:prstGeom prst="roundRect">
             <a:avLst/>
           </a:prstGeom>
           <a:solidFill>
-            <a:srgbClr val="151D30"/>
+            <a:srgbClr val="FFFFFF"/>
           </a:solidFill>
           <a:ln w="19050">
             <a:solidFill>
-              <a:srgbClr val="243354"/>
+              <a:srgbClr val="0284C7"/>
             </a:solidFill>
           </a:ln>
         </p:spPr>
@@ -6660,101 +6988,62 @@
           </a:fontRef>
         </p:style>
         <p:txBody>
-          <a:bodyPr rtlCol="0" anchor="ctr"/>
-          <a:lstStyle/>
-          <a:p>
-            <a:pPr algn="ctr"/>
-          </a:p>
-        </p:txBody>
-      </p:sp>
-      <p:sp>
-        <p:nvSpPr>
-          <p:cNvPr id="7" name="TextBox 6"/>
-          <p:cNvSpPr txBox="1"/>
-          <p:nvPr/>
-        </p:nvSpPr>
-        <p:spPr>
-          <a:xfrm>
-            <a:off x="914400" y="1828800"/>
-            <a:ext cx="4754880" cy="1783080"/>
-          </a:xfrm>
-          <a:prstGeom prst="rect">
-            <a:avLst/>
-          </a:prstGeom>
-          <a:noFill/>
-        </p:spPr>
-        <p:txBody>
-          <a:bodyPr wrap="square">
-            <a:spAutoFit/>
-          </a:bodyPr>
-          <a:lstStyle/>
-          <a:p>
-            <a:pPr>
-              <a:spcAft>
-                <a:spcPts val="1000"/>
-              </a:spcAft>
-              <a:defRPr sz="1600" b="1">
-                <a:solidFill>
-                  <a:srgbClr val="38BDF8"/>
-                </a:solidFill>
-              </a:defRPr>
-            </a:pPr>
-            <a:r>
-              <a:t>Q1: Why clone() instead of fork()?</a:t>
-            </a:r>
-          </a:p>
-          <a:p>
-            <a:pPr>
-              <a:spcAft>
-                <a:spcPts val="800"/>
-              </a:spcAft>
-              <a:defRPr sz="1300">
-                <a:solidFill>
-                  <a:srgbClr val="F1F5F9"/>
-                </a:solidFill>
-              </a:defRPr>
-            </a:pPr>
-            <a:r>
-              <a:t>•  fork() duplicates the process within identical namespaces.</a:t>
-            </a:r>
-          </a:p>
-          <a:p>
-            <a:pPr>
-              <a:spcAft>
-                <a:spcPts val="800"/>
-              </a:spcAft>
-              <a:defRPr sz="1300">
-                <a:solidFill>
-                  <a:srgbClr val="F1F5F9"/>
-                </a:solidFill>
-              </a:defRPr>
-            </a:pPr>
-            <a:r>
-              <a:t>•  clone() accepts flags like CLONE_NEWPID and CLONE_NEWUTS to instantiate the child inside brand-new, isolated kernel namespaces.</a:t>
-            </a:r>
-          </a:p>
-        </p:txBody>
-      </p:sp>
-      <p:sp>
-        <p:nvSpPr>
-          <p:cNvPr id="8" name="Rounded Rectangle 7"/>
+          <a:bodyPr rtlCol="0" anchor="ctr" wrap="square"/>
+          <a:lstStyle/>
+          <a:p>
+            <a:pPr algn="ctr">
+              <a:defRPr sz="1400" b="1">
+                <a:solidFill>
+                  <a:srgbClr val="0284C7"/>
+                </a:solidFill>
+              </a:defRPr>
+            </a:pPr>
+            <a:r>
+              <a:t>1. Process Virtualization (CO: 1 &amp; 5)</a:t>
+            </a:r>
+          </a:p>
+          <a:p>
+            <a:pPr>
+              <a:defRPr sz="1100">
+                <a:solidFill>
+                  <a:srgbClr val="0F172A"/>
+                </a:solidFill>
+              </a:defRPr>
+            </a:pPr>
+            <a:r>
+              <a:t>• Container Process reports PID = 1; Parent PID = 0.</a:t>
+            </a:r>
+            <a:br/>
+            <a:r>
+              <a:t>• Host operating system processes (47 active) are completely hidden.</a:t>
+            </a:r>
+            <a:br/>
+            <a:r>
+              <a:t>• Hostname virtualized to 'isolated-box' without altering host.</a:t>
+            </a:r>
+          </a:p>
+        </p:txBody>
+      </p:sp>
+      <p:sp>
+        <p:nvSpPr>
+          <p:cNvPr id="7" name="Rounded Rectangle 6"/>
           <p:cNvSpPr/>
           <p:nvPr/>
         </p:nvSpPr>
         <p:spPr>
           <a:xfrm>
-            <a:off x="6217920" y="1645920"/>
-            <a:ext cx="5120640" cy="2148840"/>
+            <a:off x="6217920" y="1600200"/>
+            <a:ext cx="5120640" cy="2194560"/>
           </a:xfrm>
           <a:prstGeom prst="roundRect">
             <a:avLst/>
           </a:prstGeom>
           <a:solidFill>
-            <a:srgbClr val="151D30"/>
+            <a:srgbClr val="FFFFFF"/>
           </a:solidFill>
           <a:ln w="19050">
             <a:solidFill>
-              <a:srgbClr val="243354"/>
+              <a:srgbClr val="D97706"/>
             </a:solidFill>
           </a:ln>
         </p:spPr>
@@ -6773,101 +7062,62 @@
           </a:fontRef>
         </p:style>
         <p:txBody>
-          <a:bodyPr rtlCol="0" anchor="ctr"/>
-          <a:lstStyle/>
-          <a:p>
-            <a:pPr algn="ctr"/>
-          </a:p>
-        </p:txBody>
-      </p:sp>
-      <p:sp>
-        <p:nvSpPr>
-          <p:cNvPr id="9" name="TextBox 8"/>
-          <p:cNvSpPr txBox="1"/>
-          <p:nvPr/>
-        </p:nvSpPr>
-        <p:spPr>
-          <a:xfrm>
-            <a:off x="6400800" y="1828800"/>
-            <a:ext cx="4754880" cy="1783080"/>
-          </a:xfrm>
-          <a:prstGeom prst="rect">
-            <a:avLst/>
-          </a:prstGeom>
-          <a:noFill/>
-        </p:spPr>
-        <p:txBody>
-          <a:bodyPr wrap="square">
-            <a:spAutoFit/>
-          </a:bodyPr>
-          <a:lstStyle/>
-          <a:p>
-            <a:pPr>
-              <a:spcAft>
-                <a:spcPts val="1000"/>
-              </a:spcAft>
-              <a:defRPr sz="1600" b="1">
-                <a:solidFill>
-                  <a:srgbClr val="818CF8"/>
-                </a:solidFill>
-              </a:defRPr>
-            </a:pPr>
-            <a:r>
-              <a:t>Q2: Why did memory limit trigger SIGKILL?</a:t>
-            </a:r>
-          </a:p>
-          <a:p>
-            <a:pPr>
-              <a:spcAft>
-                <a:spcPts val="800"/>
-              </a:spcAft>
-              <a:defRPr sz="1300">
-                <a:solidFill>
-                  <a:srgbClr val="F1F5F9"/>
-                </a:solidFill>
-              </a:defRPr>
-            </a:pPr>
-            <a:r>
-              <a:t>•  Linux uses optimistic memory overcommit &amp; demand paging.</a:t>
-            </a:r>
-          </a:p>
-          <a:p>
-            <a:pPr>
-              <a:spcAft>
-                <a:spcPts val="800"/>
-              </a:spcAft>
-              <a:defRPr sz="1300">
-                <a:solidFill>
-                  <a:srgbClr val="F1F5F9"/>
-                </a:solidFill>
-              </a:defRPr>
-            </a:pPr>
-            <a:r>
-              <a:t>•  When memset() committed physical pages exceeding memory.max with swap disabled, the kernel OOM Killer dispatched SIGKILL.</a:t>
-            </a:r>
-          </a:p>
-        </p:txBody>
-      </p:sp>
-      <p:sp>
-        <p:nvSpPr>
-          <p:cNvPr id="10" name="Rounded Rectangle 9"/>
+          <a:bodyPr rtlCol="0" anchor="ctr" wrap="square"/>
+          <a:lstStyle/>
+          <a:p>
+            <a:pPr algn="ctr">
+              <a:defRPr sz="1400" b="1">
+                <a:solidFill>
+                  <a:srgbClr val="D97706"/>
+                </a:solidFill>
+              </a:defRPr>
+            </a:pPr>
+            <a:r>
+              <a:t>2. Memory Ceiling &amp; Demand Paging (CO: 4)</a:t>
+            </a:r>
+          </a:p>
+          <a:p>
+            <a:pPr>
+              <a:defRPr sz="1100">
+                <a:solidFill>
+                  <a:srgbClr val="0F172A"/>
+                </a:solidFill>
+              </a:defRPr>
+            </a:pPr>
+            <a:r>
+              <a:t>• Workload allocated 30MB of 60MB; terminated by SIGKILL (signal 9).</a:t>
+            </a:r>
+            <a:br/>
+            <a:r>
+              <a:t>• Kernel logged 7,705 Minor Page Faults, validating Demand Paging.</a:t>
+            </a:r>
+            <a:br/>
+            <a:r>
+              <a:t>• 1 Major Page Fault; Swap disabled to force immediate OOM protection.</a:t>
+            </a:r>
+          </a:p>
+        </p:txBody>
+      </p:sp>
+      <p:sp>
+        <p:nvSpPr>
+          <p:cNvPr id="8" name="Rounded Rectangle 7"/>
           <p:cNvSpPr/>
           <p:nvPr/>
         </p:nvSpPr>
         <p:spPr>
           <a:xfrm>
-            <a:off x="731520" y="3977639"/>
-            <a:ext cx="5120640" cy="2148840"/>
+            <a:off x="731520" y="4023360"/>
+            <a:ext cx="5120640" cy="2194560"/>
           </a:xfrm>
           <a:prstGeom prst="roundRect">
             <a:avLst/>
           </a:prstGeom>
           <a:solidFill>
-            <a:srgbClr val="151D30"/>
+            <a:srgbClr val="FFFFFF"/>
           </a:solidFill>
           <a:ln w="19050">
             <a:solidFill>
-              <a:srgbClr val="243354"/>
+              <a:srgbClr val="4F46E5"/>
             </a:solidFill>
           </a:ln>
         </p:spPr>
@@ -6886,86 +7136,62 @@
           </a:fontRef>
         </p:style>
         <p:txBody>
-          <a:bodyPr rtlCol="0" anchor="ctr"/>
-          <a:lstStyle/>
-          <a:p>
-            <a:pPr algn="ctr"/>
-          </a:p>
-        </p:txBody>
-      </p:sp>
-      <p:sp>
-        <p:nvSpPr>
-          <p:cNvPr id="11" name="TextBox 10"/>
-          <p:cNvSpPr txBox="1"/>
-          <p:nvPr/>
-        </p:nvSpPr>
-        <p:spPr>
-          <a:xfrm>
-            <a:off x="914400" y="4160519"/>
-            <a:ext cx="4754880" cy="1783080"/>
-          </a:xfrm>
-          <a:prstGeom prst="rect">
-            <a:avLst/>
-          </a:prstGeom>
-          <a:noFill/>
-        </p:spPr>
-        <p:txBody>
-          <a:bodyPr wrap="square">
-            <a:spAutoFit/>
-          </a:bodyPr>
-          <a:lstStyle/>
-          <a:p>
-            <a:pPr>
-              <a:spcAft>
-                <a:spcPts val="1000"/>
-              </a:spcAft>
-              <a:defRPr sz="1600" b="1">
-                <a:solidFill>
-                  <a:srgbClr val="34D399"/>
-                </a:solidFill>
-              </a:defRPr>
-            </a:pPr>
-            <a:r>
-              <a:t>Q3: Why is an IPC pipe needed between parent &amp; child?</a:t>
-            </a:r>
-          </a:p>
-          <a:p>
-            <a:pPr>
-              <a:spcAft>
-                <a:spcPts val="800"/>
-              </a:spcAft>
-              <a:defRPr sz="1300">
-                <a:solidFill>
-                  <a:srgbClr val="F1F5F9"/>
-                </a:solidFill>
-              </a:defRPr>
-            </a:pPr>
-            <a:r>
-              <a:t>•  To eliminate a critical race condition. The child must not call execvp() before the parent finishes creating cgroups and attaching the child's PID.</a:t>
-            </a:r>
-          </a:p>
-        </p:txBody>
-      </p:sp>
-      <p:sp>
-        <p:nvSpPr>
-          <p:cNvPr id="12" name="Rounded Rectangle 11"/>
+          <a:bodyPr rtlCol="0" anchor="ctr" wrap="square"/>
+          <a:lstStyle/>
+          <a:p>
+            <a:pPr algn="ctr">
+              <a:defRPr sz="1400" b="1">
+                <a:solidFill>
+                  <a:srgbClr val="4F46E5"/>
+                </a:solidFill>
+              </a:defRPr>
+            </a:pPr>
+            <a:r>
+              <a:t>3. Proportional Fair-Share CPU Contest (CO: 2)</a:t>
+            </a:r>
+          </a:p>
+          <a:p>
+            <a:pPr>
+              <a:defRPr sz="1100">
+                <a:solidFill>
+                  <a:srgbClr val="0F172A"/>
+                </a:solidFill>
+              </a:defRPr>
+            </a:pPr>
+            <a:r>
+              <a:t>• Competing containers on CPU Core 0 with CFS weights 800 vs 200.</a:t>
+            </a:r>
+            <a:br/>
+            <a:r>
+              <a:t>• Container A CPU Time: 2.78s  |  Container B CPU Time: 0.69s.</a:t>
+            </a:r>
+            <a:br/>
+            <a:r>
+              <a:t>• Exact 4.02 : 1 execution ratio (matches theoretical 4:1 with 99.5% accuracy!).</a:t>
+            </a:r>
+          </a:p>
+        </p:txBody>
+      </p:sp>
+      <p:sp>
+        <p:nvSpPr>
+          <p:cNvPr id="9" name="Rounded Rectangle 8"/>
           <p:cNvSpPr/>
           <p:nvPr/>
         </p:nvSpPr>
         <p:spPr>
           <a:xfrm>
-            <a:off x="6217920" y="3977639"/>
-            <a:ext cx="5120640" cy="2148840"/>
+            <a:off x="6217920" y="4023360"/>
+            <a:ext cx="5120640" cy="2194560"/>
           </a:xfrm>
           <a:prstGeom prst="roundRect">
             <a:avLst/>
           </a:prstGeom>
           <a:solidFill>
-            <a:srgbClr val="151D30"/>
+            <a:srgbClr val="FFFFFF"/>
           </a:solidFill>
           <a:ln w="19050">
             <a:solidFill>
-              <a:srgbClr val="243354"/>
+              <a:srgbClr val="10B981"/>
             </a:solidFill>
           </a:ln>
         </p:spPr>
@@ -6984,62 +7210,38 @@
           </a:fontRef>
         </p:style>
         <p:txBody>
-          <a:bodyPr rtlCol="0" anchor="ctr"/>
-          <a:lstStyle/>
-          <a:p>
-            <a:pPr algn="ctr"/>
-          </a:p>
-        </p:txBody>
-      </p:sp>
-      <p:sp>
-        <p:nvSpPr>
-          <p:cNvPr id="13" name="TextBox 12"/>
-          <p:cNvSpPr txBox="1"/>
-          <p:nvPr/>
-        </p:nvSpPr>
-        <p:spPr>
-          <a:xfrm>
-            <a:off x="6400800" y="4160519"/>
-            <a:ext cx="4754880" cy="1783080"/>
-          </a:xfrm>
-          <a:prstGeom prst="rect">
-            <a:avLst/>
-          </a:prstGeom>
-          <a:noFill/>
-        </p:spPr>
-        <p:txBody>
-          <a:bodyPr wrap="square">
-            <a:spAutoFit/>
-          </a:bodyPr>
-          <a:lstStyle/>
-          <a:p>
-            <a:pPr>
-              <a:spcAft>
-                <a:spcPts val="1000"/>
-              </a:spcAft>
-              <a:defRPr sz="1600" b="1">
-                <a:solidFill>
-                  <a:srgbClr val="38BDF8"/>
-                </a:solidFill>
-              </a:defRPr>
-            </a:pPr>
-            <a:r>
-              <a:t>Q4: How did you prove CPU scheduling fairness?</a:t>
-            </a:r>
-          </a:p>
-          <a:p>
-            <a:pPr>
-              <a:spcAft>
-                <a:spcPts val="800"/>
-              </a:spcAft>
-              <a:defRPr sz="1300">
-                <a:solidFill>
-                  <a:srgbClr val="F1F5F9"/>
-                </a:solidFill>
-              </a:defRPr>
-            </a:pPr>
-            <a:r>
-              <a:t>•  Two containers with CFS weights 800 vs 200 ran concurrently on CPU 0. CFS allocated 2.78s and 0.69s, verifying the theoretical 4:1 ratio with 99.5% accuracy.</a:t>
+          <a:bodyPr rtlCol="0" anchor="ctr" wrap="square"/>
+          <a:lstStyle/>
+          <a:p>
+            <a:pPr algn="ctr">
+              <a:defRPr sz="1400" b="1">
+                <a:solidFill>
+                  <a:srgbClr val="10B981"/>
+                </a:solidFill>
+              </a:defRPr>
+            </a:pPr>
+            <a:r>
+              <a:t>4. Fork Bomb &amp; PCB Table Defense (CO: 1 &amp; 3)</a:t>
+            </a:r>
+          </a:p>
+          <a:p>
+            <a:pPr>
+              <a:defRPr sz="1100">
+                <a:solidFill>
+                  <a:srgbClr val="0F172A"/>
+                </a:solidFill>
+              </a:defRPr>
+            </a:pPr>
+            <a:r>
+              <a:t>• Stress test attempted to spawn 50 concurrent processes.</a:t>
+            </a:r>
+            <a:br/>
+            <a:r>
+              <a:t>• Cgroups pids.max = 10 capped execution; Children 1 - 9 spawned.</a:t>
+            </a:r>
+            <a:br/>
+            <a:r>
+              <a:t>• 10th fork() blocked with errno 11 (EAGAIN); host OS remained responsive.</a:t>
             </a:r>
           </a:p>
         </p:txBody>
@@ -7077,11 +7279,11 @@
             <a:avLst/>
           </a:prstGeom>
           <a:solidFill>
-            <a:srgbClr val="0B0F19"/>
+            <a:srgbClr val="F8FAFC"/>
           </a:solidFill>
           <a:ln>
             <a:solidFill>
-              <a:srgbClr val="0B0F19"/>
+              <a:srgbClr val="F8FAFC"/>
             </a:solidFill>
           </a:ln>
         </p:spPr>
@@ -7115,18 +7317,18 @@
         </p:nvSpPr>
         <p:spPr>
           <a:xfrm>
-            <a:off x="4114800" y="1097280"/>
-            <a:ext cx="3959352" cy="411480"/>
+            <a:off x="3931920" y="1005840"/>
+            <a:ext cx="4297680" cy="411480"/>
           </a:xfrm>
           <a:prstGeom prst="roundRect">
             <a:avLst/>
           </a:prstGeom>
           <a:solidFill>
-            <a:srgbClr val="0F233C"/>
+            <a:srgbClr val="E0F2FE"/>
           </a:solidFill>
           <a:ln>
             <a:solidFill>
-              <a:srgbClr val="38BDF8"/>
+              <a:srgbClr val="0284C7"/>
             </a:solidFill>
           </a:ln>
         </p:spPr>
@@ -7151,12 +7353,12 @@
             <a:pPr algn="ctr">
               <a:defRPr sz="1100" b="1">
                 <a:solidFill>
-                  <a:srgbClr val="38BDF8"/>
-                </a:solidFill>
-              </a:defRPr>
-            </a:pPr>
-            <a:r>
-              <a:t>EVALUATION DASHBOARD</a:t>
+                  <a:srgbClr val="0284C7"/>
+                </a:solidFill>
+              </a:defRPr>
+            </a:pPr>
+            <a:r>
+              <a:t>EVALUATION &amp; LIVE DEMONSTRATION</a:t>
             </a:r>
           </a:p>
         </p:txBody>
@@ -7169,7 +7371,7 @@
         </p:nvSpPr>
         <p:spPr>
           <a:xfrm>
-            <a:off x="914400" y="1645920"/>
+            <a:off x="914400" y="1554480"/>
             <a:ext cx="10360152" cy="1371600"/>
           </a:xfrm>
           <a:prstGeom prst="rect">
@@ -7186,12 +7388,12 @@
             <a:pPr algn="ctr">
               <a:defRPr sz="3600" b="1">
                 <a:solidFill>
-                  <a:srgbClr val="38BDF8"/>
-                </a:solidFill>
-              </a:defRPr>
-            </a:pPr>
-            <a:r>
-              <a:t>Ready for Live Demonstration</a:t>
+                  <a:srgbClr val="0F172A"/>
+                </a:solidFill>
+              </a:defRPr>
+            </a:pPr>
+            <a:r>
+              <a:t>Interactive Project Demonstration</a:t>
             </a:r>
           </a:p>
           <a:p>
@@ -7199,14 +7401,14 @@
               <a:spcBef>
                 <a:spcPts val="800"/>
               </a:spcBef>
-              <a:defRPr sz="1600">
-                <a:solidFill>
-                  <a:srgbClr val="94A3B8"/>
-                </a:solidFill>
-              </a:defRPr>
-            </a:pPr>
-            <a:r>
-              <a:t>Complete C Runtime Covering CO: 1 to CO: 5 with Master Interactive Menu and Real-Time Kernel Metrics</a:t>
+              <a:defRPr sz="1500">
+                <a:solidFill>
+                  <a:srgbClr val="475569"/>
+                </a:solidFill>
+              </a:defRPr>
+            </a:pPr>
+            <a:r>
+              <a:t>Complete C99 Runtime Covering CO: 1 to CO: 5 with Master Interactive Menu and Real-Time Kernel Metrics</a:t>
             </a:r>
           </a:p>
         </p:txBody>
@@ -7220,17 +7422,17 @@
         <p:spPr>
           <a:xfrm>
             <a:off x="2926080" y="3200400"/>
-            <a:ext cx="6336792" cy="1097280"/>
+            <a:ext cx="6336792" cy="1188720"/>
           </a:xfrm>
           <a:prstGeom prst="roundRect">
             <a:avLst/>
           </a:prstGeom>
           <a:solidFill>
-            <a:srgbClr val="090D16"/>
+            <a:srgbClr val="FFFFFF"/>
           </a:solidFill>
           <a:ln w="25400">
             <a:solidFill>
-              <a:srgbClr val="38BDF8"/>
+              <a:srgbClr val="0284C7"/>
             </a:solidFill>
           </a:ln>
         </p:spPr>
@@ -7255,7 +7457,7 @@
             <a:pPr algn="ctr">
               <a:defRPr sz="2200" b="1">
                 <a:solidFill>
-                  <a:srgbClr val="38BDF8"/>
+                  <a:srgbClr val="0284C7"/>
                 </a:solidFill>
               </a:defRPr>
             </a:pPr>
@@ -7265,14 +7467,17 @@
           </a:p>
           <a:p>
             <a:pPr algn="ctr">
+              <a:spcBef>
+                <a:spcPts val="400"/>
+              </a:spcBef>
               <a:defRPr sz="1200">
                 <a:solidFill>
-                  <a:srgbClr val="94A3B8"/>
-                </a:solidFill>
-              </a:defRPr>
-            </a:pPr>
-            <a:r>
-              <a:t>(Or double-click Run-MiniContainer.bat on Windows Desktop)</a:t>
+                  <a:srgbClr val="475569"/>
+                </a:solidFill>
+              </a:defRPr>
+            </a:pPr>
+            <a:r>
+              <a:t>(Or double-click Run-MiniContainer.bat directly on your Windows Desktop)</a:t>
             </a:r>
           </a:p>
         </p:txBody>
@@ -7285,7 +7490,7 @@
         </p:nvSpPr>
         <p:spPr>
           <a:xfrm>
-            <a:off x="914400" y="4572000"/>
+            <a:off x="914400" y="4663440"/>
             <a:ext cx="10360152" cy="1371600"/>
           </a:xfrm>
           <a:prstGeom prst="rect">
@@ -7302,7 +7507,7 @@
             <a:pPr algn="ctr">
               <a:defRPr sz="1600" b="1">
                 <a:solidFill>
-                  <a:srgbClr val="F1F5F9"/>
+                  <a:srgbClr val="0F172A"/>
                 </a:solidFill>
               </a:defRPr>
             </a:pPr>
@@ -7317,7 +7522,7 @@
               </a:spcBef>
               <a:defRPr sz="1400">
                 <a:solidFill>
-                  <a:srgbClr val="818CF8"/>
+                  <a:srgbClr val="0284C7"/>
                 </a:solidFill>
               </a:defRPr>
             </a:pPr>

</xml_diff>